<commit_message>
fix: hoàn tất các finding P1/P2 của review tiền tốt nghiệp (khóa lộ trình học F1, đóng vòng duyệt nội dung F2, chặn hard-delete mất dữ liệu học tập F3, transaction serializable chống race F4/F5, siết role student F6, chặn làm lại sau khi đạt F7, khóa passScore hồi tố F8, completeness khi gửi duyệt F9, lazy-load route F11, ESLint + CI gate F12); cập nhật tài liệu: số test 318/324 -> 344, điền tên học viên/GVHD, sửa cổng PostgreSQL
</commit_message>
<xml_diff>
--- a/docs/SLIDE-BAO-VE-LearnQuiz.pptx
+++ b/docs/SLIDE-BAO-VE-LearnQuiz.pptx
@@ -5032,7 +5032,7 @@
                 <a:ea typeface="Cambria" pitchFamily="34" charset="-122"/>
                 <a:cs typeface="Cambria" pitchFamily="34" charset="-120"/>
               </a:rPr>
-              <a:t>Kiểm thử tự động: 318 / 318 phép khẳng định</a:t>
+              <a:t>Kiểm thử tự động: 344 / 344 phép khẳng định</a:t>
             </a:r>
             <a:endParaRPr lang="en-US" sz="3200" dirty="0"/>
           </a:p>
@@ -7170,7 +7170,7 @@
                 <a:ea typeface="Cambria" pitchFamily="34" charset="-122"/>
                 <a:cs typeface="Cambria" pitchFamily="34" charset="-120"/>
               </a:rPr>
-              <a:t>318/318</a:t>
+              <a:t>344/344</a:t>
             </a:r>
             <a:endParaRPr lang="en-US" sz="3400" dirty="0"/>
           </a:p>
@@ -9347,7 +9347,7 @@
                 <a:ea typeface="Calibri" pitchFamily="34" charset="-122"/>
                 <a:cs typeface="Calibri" pitchFamily="34" charset="-120"/>
               </a:rPr>
-              <a:t>318 phép kiểm · Docker · CI/CD · Render + Vercel</a:t>
+              <a:t>344 phép kiểm · Docker · CI/CD · Render + Vercel</a:t>
             </a:r>
             <a:endParaRPr lang="en-US" sz="1200" dirty="0"/>
           </a:p>

</xml_diff>

<commit_message>
fix: complete graduation hardening
</commit_message>
<xml_diff>
--- a/docs/SLIDE-BAO-VE-LearnQuiz.pptx
+++ b/docs/SLIDE-BAO-VE-LearnQuiz.pptx
@@ -1,10 +1,10 @@
 
 <file path=ppt/presentation.xml><?xml version="1.0" encoding="utf-8"?>
 <p:presentation xmlns:a="http://schemas.openxmlformats.org/drawingml/2006/main" xmlns:r="http://schemas.openxmlformats.org/officeDocument/2006/relationships" xmlns:p="http://schemas.openxmlformats.org/presentationml/2006/main" saveSubsetFonts="1" autoCompressPictures="0">
-  <p:sldMasterIdLst>
+  <p:sldMasterIdLst xmlns:a="http://schemas.openxmlformats.org/drawingml/2006/main" xmlns:r="http://schemas.openxmlformats.org/officeDocument/2006/relationships" xmlns:p="http://schemas.openxmlformats.org/presentationml/2006/main">
     <p:sldMasterId id="2147483648" r:id="rId1"/>
   </p:sldMasterIdLst>
-  <p:sldIdLst>
+  <p:sldIdLst xmlns:a="http://schemas.openxmlformats.org/drawingml/2006/main" xmlns:r="http://schemas.openxmlformats.org/officeDocument/2006/relationships" xmlns:p="http://schemas.openxmlformats.org/presentationml/2006/main">
     <p:sldId id="256" r:id="rId2"/>
     <p:sldId id="257" r:id="rId3"/>
     <p:sldId id="258" r:id="rId4"/>
@@ -23,12 +23,9 @@
     <p:sldId id="271" r:id="rId17"/>
     <p:sldId id="272" r:id="rId18"/>
   </p:sldIdLst>
-  <p:notesMasterIdLst>
-    <p:notesMasterId r:id="rId19"/>
-  </p:notesMasterIdLst>
-  <p:sldSz cx="12192000" cy="6858000"/>
-  <p:notesSz cx="6858000" cy="12192000"/>
-  <p:defaultTextStyle>
+  <p:sldSz xmlns:a="http://schemas.openxmlformats.org/drawingml/2006/main" xmlns:r="http://schemas.openxmlformats.org/officeDocument/2006/relationships" xmlns:p="http://schemas.openxmlformats.org/presentationml/2006/main" cx="12192000" cy="6858000"/>
+  <p:notesSz xmlns:a="http://schemas.openxmlformats.org/drawingml/2006/main" xmlns:r="http://schemas.openxmlformats.org/officeDocument/2006/relationships" xmlns:p="http://schemas.openxmlformats.org/presentationml/2006/main" cx="6858000" cy="12192000"/>
+  <p:defaultTextStyle xmlns:a="http://schemas.openxmlformats.org/drawingml/2006/main" xmlns:r="http://schemas.openxmlformats.org/officeDocument/2006/relationships" xmlns:p="http://schemas.openxmlformats.org/presentationml/2006/main">
     <a:lvl1pPr marL="0" algn="l" defTabSz="914400" rtl="0" eaLnBrk="1" latinLnBrk="0" hangingPunct="1">
       <a:defRPr sz="1800" kern="1200">
         <a:solidFill>
@@ -163,7 +160,7 @@
               <a:lstStyle/>
               <a:p>
                 <a:pPr>
-                  <a:defRPr b="0" i="0" strike="noStrike" sz="1100" u="none">
+                  <a:defRPr sz="1100" b="0" i="0" u="none" strike="noStrike">
                     <a:solidFill>
                       <a:srgbClr val="1B1B1F"/>
                     </a:solidFill>
@@ -181,71 +178,63 @@
             <c:showLeaderLines val="0"/>
           </c:dLbls>
           <c:cat>
-            <c:multiLvlStrRef>
-              <c:f>Sheet1!$A$2:$A$9</c:f>
-              <c:multiLvlStrCache>
-                <c:ptCount val="8"/>
-                <c:lvl>
-                  <c:pt idx="0">
-                    <c:v>grader</c:v>
-                  </c:pt>
-                  <c:pt idx="1">
-                    <c:v>workflow</c:v>
-                  </c:pt>
-                  <c:pt idx="2">
-                    <c:v>schema</c:v>
-                  </c:pt>
-                  <c:pt idx="3">
-                    <c:v>gemini</c:v>
-                  </c:pt>
-                  <c:pt idx="4">
-                    <c:v>quizService</c:v>
-                  </c:pt>
-                  <c:pt idx="5">
-                    <c:v>adminService</c:v>
-                  </c:pt>
-                  <c:pt idx="6">
-                    <c:v>aiService</c:v>
-                  </c:pt>
-                  <c:pt idx="7">
-                    <c:v>api</c:v>
-                  </c:pt>
-                </c:lvl>
-              </c:multiLvlStrCache>
-            </c:multiLvlStrRef>
+            <c:strLit>
+              <c:ptCount val="8"/>
+              <c:pt idx="0">
+                <c:v>grader</c:v>
+              </c:pt>
+              <c:pt idx="1">
+                <c:v>workflow</c:v>
+              </c:pt>
+              <c:pt idx="2">
+                <c:v>schema</c:v>
+              </c:pt>
+              <c:pt idx="3">
+                <c:v>gemini</c:v>
+              </c:pt>
+              <c:pt idx="4">
+                <c:v>quizService</c:v>
+              </c:pt>
+              <c:pt idx="5">
+                <c:v>adminService</c:v>
+              </c:pt>
+              <c:pt idx="6">
+                <c:v>aiService</c:v>
+              </c:pt>
+              <c:pt idx="7">
+                <c:v>HTTP + hồi quy</c:v>
+              </c:pt>
+            </c:strLit>
           </c:cat>
           <c:val>
-            <c:numRef>
-              <c:f>Sheet1!$B$2:$B$9</c:f>
-              <c:numCache>
-                <c:formatCode>General</c:formatCode>
-                <c:ptCount val="8"/>
-                <c:pt idx="0">
-                  <c:v>24</c:v>
-                </c:pt>
-                <c:pt idx="1">
-                  <c:v>30</c:v>
-                </c:pt>
-                <c:pt idx="2">
-                  <c:v>31</c:v>
-                </c:pt>
-                <c:pt idx="3">
-                  <c:v>18</c:v>
-                </c:pt>
-                <c:pt idx="4">
-                  <c:v>47</c:v>
-                </c:pt>
-                <c:pt idx="5">
-                  <c:v>75</c:v>
-                </c:pt>
-                <c:pt idx="6">
-                  <c:v>36</c:v>
-                </c:pt>
-                <c:pt idx="7">
-                  <c:v>57</c:v>
-                </c:pt>
-              </c:numCache>
-            </c:numRef>
+            <c:numLit>
+              <c:formatCode>General</c:formatCode>
+              <c:ptCount val="8"/>
+              <c:pt idx="0">
+                <c:v>24</c:v>
+              </c:pt>
+              <c:pt idx="1">
+                <c:v>30</c:v>
+              </c:pt>
+              <c:pt idx="2">
+                <c:v>31</c:v>
+              </c:pt>
+              <c:pt idx="3">
+                <c:v>18</c:v>
+              </c:pt>
+              <c:pt idx="4">
+                <c:v>49</c:v>
+              </c:pt>
+              <c:pt idx="5">
+                <c:v>75</c:v>
+              </c:pt>
+              <c:pt idx="6">
+                <c:v>36</c:v>
+              </c:pt>
+              <c:pt idx="7">
+                <c:v>81</c:v>
+              </c:pt>
+            </c:numLit>
           </c:val>
         </c:ser>
         <c:dLbls>
@@ -255,7 +244,7 @@
             <a:lstStyle/>
             <a:p>
               <a:pPr>
-                <a:defRPr b="0" i="0" strike="noStrike" sz="1100" u="none">
+                <a:defRPr sz="1100" b="0" i="0" u="none" strike="noStrike">
                   <a:solidFill>
                     <a:srgbClr val="1B1B1F"/>
                   </a:solidFill>
@@ -276,7 +265,6 @@
         <c:overlap val="0"/>
         <c:axId val="2094734554"/>
         <c:axId val="2094734552"/>
-        <c:axId val="2094734556"/>
       </c:barChart>
       <c:catAx>
         <c:axId val="2094734554"/>
@@ -2641,11 +2629,11 @@
           <a:bodyPr wrap="square" lIns="0" tIns="0" rIns="0" bIns="0" rtlCol="0" anchor="ctr"/>
           <a:lstStyle/>
           <a:p>
-            <a:pPr indent="0" marL="0">
-              <a:buNone/>
-            </a:pPr>
-            <a:r>
-              <a:rPr lang="en-US" sz="1300" b="1" spc="300" kern="0" dirty="0">
+            <a:pPr marL="0" indent="0">
+              <a:buNone/>
+            </a:pPr>
+            <a:r>
+              <a:rPr lang="en-US" sz="1300" b="1" kern="0" spc="300" dirty="0">
                 <a:solidFill>
                   <a:srgbClr val="CADCFC"/>
                 </a:solidFill>
@@ -2680,7 +2668,7 @@
           <a:bodyPr wrap="square" lIns="0" tIns="0" rIns="0" bIns="0" rtlCol="0" anchor="ctr"/>
           <a:lstStyle/>
           <a:p>
-            <a:pPr indent="0" marL="0">
+            <a:pPr marL="0" indent="0">
               <a:buNone/>
             </a:pPr>
             <a:r>
@@ -2719,7 +2707,7 @@
           <a:bodyPr wrap="square" lIns="0" tIns="0" rIns="0" bIns="0" rtlCol="0" anchor="ctr"/>
           <a:lstStyle/>
           <a:p>
-            <a:pPr indent="0" marL="0">
+            <a:pPr marL="0" indent="0">
               <a:buNone/>
             </a:pPr>
             <a:r>
@@ -2785,7 +2773,7 @@
           <a:bodyPr wrap="square" lIns="0" tIns="0" rIns="0" bIns="0" rtlCol="0" anchor="ctr"/>
           <a:lstStyle/>
           <a:p>
-            <a:pPr indent="0" marL="0">
+            <a:pPr marL="0" indent="0">
               <a:buNone/>
             </a:pPr>
             <a:r>
@@ -2824,7 +2812,7 @@
           <a:bodyPr wrap="square" lIns="0" tIns="0" rIns="0" bIns="0" rtlCol="0" anchor="ctr"/>
           <a:lstStyle/>
           <a:p>
-            <a:pPr indent="0" marL="0">
+            <a:pPr marL="0" indent="0">
               <a:buNone/>
             </a:pPr>
             <a:r>
@@ -2863,7 +2851,7 @@
           <a:bodyPr wrap="square" lIns="0" tIns="0" rIns="0" bIns="0" rtlCol="0" anchor="ctr"/>
           <a:lstStyle/>
           <a:p>
-            <a:pPr indent="0" marL="0">
+            <a:pPr marL="0" indent="0">
               <a:buNone/>
             </a:pPr>
             <a:r>
@@ -2902,7 +2890,7 @@
           <a:bodyPr wrap="square" lIns="0" tIns="0" rIns="0" bIns="0" rtlCol="0" anchor="ctr"/>
           <a:lstStyle/>
           <a:p>
-            <a:pPr indent="0" marL="0">
+            <a:pPr marL="0" indent="0">
               <a:buNone/>
             </a:pPr>
             <a:r>
@@ -2941,7 +2929,7 @@
           <a:bodyPr wrap="square" lIns="0" tIns="0" rIns="0" bIns="0" rtlCol="0" anchor="ctr"/>
           <a:lstStyle/>
           <a:p>
-            <a:pPr indent="0" marL="0">
+            <a:pPr marL="0" indent="0">
               <a:buNone/>
             </a:pPr>
             <a:r>
@@ -3012,11 +3000,11 @@
           <a:bodyPr wrap="square" lIns="0" tIns="0" rIns="0" bIns="0" rtlCol="0" anchor="ctr"/>
           <a:lstStyle/>
           <a:p>
-            <a:pPr indent="0" marL="0">
-              <a:buNone/>
-            </a:pPr>
-            <a:r>
-              <a:rPr lang="en-US" sz="1200" b="1" spc="200" kern="0" dirty="0">
+            <a:pPr marL="0" indent="0">
+              <a:buNone/>
+            </a:pPr>
+            <a:r>
+              <a:rPr lang="en-US" sz="1200" b="1" kern="0" spc="200" dirty="0">
                 <a:solidFill>
                   <a:srgbClr val="5A5F73"/>
                 </a:solidFill>
@@ -3051,7 +3039,7 @@
           <a:bodyPr wrap="square" lIns="0" tIns="0" rIns="0" bIns="0" rtlCol="0" anchor="ctr"/>
           <a:lstStyle/>
           <a:p>
-            <a:pPr indent="0" marL="0">
+            <a:pPr marL="0" indent="0">
               <a:buNone/>
             </a:pPr>
             <a:r>
@@ -3115,7 +3103,7 @@
           <a:bodyPr wrap="square" lIns="0" tIns="0" rIns="0" bIns="0" rtlCol="0" anchor="ctr"/>
           <a:lstStyle/>
           <a:p>
-            <a:pPr algn="ctr" indent="0" marL="0">
+            <a:pPr marL="0" indent="0" algn="ctr">
               <a:buNone/>
             </a:pPr>
             <a:r>
@@ -3154,7 +3142,7 @@
           <a:bodyPr wrap="square" lIns="0" tIns="0" rIns="0" bIns="0" rtlCol="0" anchor="ctr"/>
           <a:lstStyle/>
           <a:p>
-            <a:pPr indent="0" marL="0">
+            <a:pPr marL="0" indent="0">
               <a:buNone/>
             </a:pPr>
             <a:r>
@@ -3193,7 +3181,7 @@
           <a:bodyPr wrap="square" lIns="0" tIns="0" rIns="0" bIns="0" rtlCol="0" anchor="ctr"/>
           <a:lstStyle/>
           <a:p>
-            <a:pPr indent="0" marL="0">
+            <a:pPr marL="0" indent="0">
               <a:buNone/>
             </a:pPr>
             <a:r>
@@ -3280,7 +3268,7 @@
           <a:bodyPr wrap="square" lIns="0" tIns="0" rIns="0" bIns="0" rtlCol="0" anchor="ctr"/>
           <a:lstStyle/>
           <a:p>
-            <a:pPr algn="ctr" indent="0" marL="0">
+            <a:pPr marL="0" indent="0" algn="ctr">
               <a:buNone/>
             </a:pPr>
             <a:r>
@@ -3319,7 +3307,7 @@
           <a:bodyPr wrap="square" lIns="0" tIns="0" rIns="0" bIns="0" rtlCol="0" anchor="ctr"/>
           <a:lstStyle/>
           <a:p>
-            <a:pPr indent="0" marL="0">
+            <a:pPr marL="0" indent="0">
               <a:buNone/>
             </a:pPr>
             <a:r>
@@ -3358,7 +3346,7 @@
           <a:bodyPr wrap="square" lIns="0" tIns="0" rIns="0" bIns="0" rtlCol="0" anchor="ctr"/>
           <a:lstStyle/>
           <a:p>
-            <a:pPr indent="0" marL="0">
+            <a:pPr marL="0" indent="0">
               <a:buNone/>
             </a:pPr>
             <a:r>
@@ -3445,7 +3433,7 @@
           <a:bodyPr wrap="square" lIns="0" tIns="0" rIns="0" bIns="0" rtlCol="0" anchor="ctr"/>
           <a:lstStyle/>
           <a:p>
-            <a:pPr algn="ctr" indent="0" marL="0">
+            <a:pPr marL="0" indent="0" algn="ctr">
               <a:buNone/>
             </a:pPr>
             <a:r>
@@ -3484,7 +3472,7 @@
           <a:bodyPr wrap="square" lIns="0" tIns="0" rIns="0" bIns="0" rtlCol="0" anchor="ctr"/>
           <a:lstStyle/>
           <a:p>
-            <a:pPr indent="0" marL="0">
+            <a:pPr marL="0" indent="0">
               <a:buNone/>
             </a:pPr>
             <a:r>
@@ -3523,7 +3511,7 @@
           <a:bodyPr wrap="square" lIns="0" tIns="0" rIns="0" bIns="0" rtlCol="0" anchor="ctr"/>
           <a:lstStyle/>
           <a:p>
-            <a:pPr indent="0" marL="0">
+            <a:pPr marL="0" indent="0">
               <a:buNone/>
             </a:pPr>
             <a:r>
@@ -3610,7 +3598,7 @@
           <a:bodyPr wrap="square" lIns="0" tIns="0" rIns="0" bIns="0" rtlCol="0" anchor="ctr"/>
           <a:lstStyle/>
           <a:p>
-            <a:pPr algn="ctr" indent="0" marL="0">
+            <a:pPr marL="0" indent="0" algn="ctr">
               <a:buNone/>
             </a:pPr>
             <a:r>
@@ -3649,7 +3637,7 @@
           <a:bodyPr wrap="square" lIns="0" tIns="0" rIns="0" bIns="0" rtlCol="0" anchor="ctr"/>
           <a:lstStyle/>
           <a:p>
-            <a:pPr indent="0" marL="0">
+            <a:pPr marL="0" indent="0">
               <a:buNone/>
             </a:pPr>
             <a:r>
@@ -3688,7 +3676,7 @@
           <a:bodyPr wrap="square" lIns="0" tIns="0" rIns="0" bIns="0" rtlCol="0" anchor="ctr"/>
           <a:lstStyle/>
           <a:p>
-            <a:pPr indent="0" marL="0">
+            <a:pPr marL="0" indent="0">
               <a:buNone/>
             </a:pPr>
             <a:r>
@@ -3775,7 +3763,7 @@
           <a:bodyPr wrap="square" lIns="0" tIns="0" rIns="0" bIns="0" rtlCol="0" anchor="ctr"/>
           <a:lstStyle/>
           <a:p>
-            <a:pPr algn="ctr" indent="0" marL="0">
+            <a:pPr marL="0" indent="0" algn="ctr">
               <a:buNone/>
             </a:pPr>
             <a:r>
@@ -3814,7 +3802,7 @@
           <a:bodyPr wrap="square" lIns="0" tIns="0" rIns="0" bIns="0" rtlCol="0" anchor="ctr"/>
           <a:lstStyle/>
           <a:p>
-            <a:pPr indent="0" marL="0">
+            <a:pPr marL="0" indent="0">
               <a:buNone/>
             </a:pPr>
             <a:r>
@@ -3853,7 +3841,7 @@
           <a:bodyPr wrap="square" lIns="0" tIns="0" rIns="0" bIns="0" rtlCol="0" anchor="ctr"/>
           <a:lstStyle/>
           <a:p>
-            <a:pPr indent="0" marL="0">
+            <a:pPr marL="0" indent="0">
               <a:buNone/>
             </a:pPr>
             <a:r>
@@ -3897,7 +3885,7 @@
             <a:prstDash val="solid"/>
           </a:ln>
           <a:effectLst>
-            <a:outerShdw sx="100000" sy="100000" kx="0" ky="0" algn="bl" rotWithShape="0" blurRad="101600" dist="12700" dir="5400000">
+            <a:outerShdw blurRad="101600" dist="12700" dir="5400000" sx="100000" sy="100000" kx="0" ky="0" algn="bl" rotWithShape="0">
               <a:srgbClr val="000000">
                 <a:alpha val="8000"/>
               </a:srgbClr>
@@ -3926,7 +3914,7 @@
           <a:bodyPr wrap="square" lIns="0" tIns="0" rIns="0" bIns="0" rtlCol="0" anchor="ctr"/>
           <a:lstStyle/>
           <a:p>
-            <a:pPr indent="0" marL="0">
+            <a:pPr marL="0" indent="0">
               <a:buNone/>
             </a:pPr>
             <a:r>
@@ -3965,7 +3953,7 @@
           <a:bodyPr wrap="square" lIns="0" tIns="0" rIns="0" bIns="0" rtlCol="0" anchor="ctr"/>
           <a:lstStyle/>
           <a:p>
-            <a:pPr indent="0" marL="0">
+            <a:pPr marL="0" indent="0">
               <a:buNone/>
             </a:pPr>
             <a:r>
@@ -4009,7 +3997,7 @@
             <a:prstDash val="solid"/>
           </a:ln>
           <a:effectLst>
-            <a:outerShdw sx="100000" sy="100000" kx="0" ky="0" algn="bl" rotWithShape="0" blurRad="101600" dist="12700" dir="5400000">
+            <a:outerShdw blurRad="101600" dist="12700" dir="5400000" sx="100000" sy="100000" kx="0" ky="0" algn="bl" rotWithShape="0">
               <a:srgbClr val="000000">
                 <a:alpha val="8000"/>
               </a:srgbClr>
@@ -4038,7 +4026,7 @@
           <a:bodyPr wrap="square" lIns="0" tIns="0" rIns="0" bIns="0" rtlCol="0" anchor="ctr"/>
           <a:lstStyle/>
           <a:p>
-            <a:pPr indent="0" marL="0">
+            <a:pPr marL="0" indent="0">
               <a:buNone/>
             </a:pPr>
             <a:r>
@@ -4077,7 +4065,7 @@
           <a:bodyPr wrap="square" lIns="0" tIns="0" rIns="0" bIns="0" rtlCol="0" anchor="ctr"/>
           <a:lstStyle/>
           <a:p>
-            <a:pPr indent="0" marL="0">
+            <a:pPr marL="0" indent="0">
               <a:buNone/>
             </a:pPr>
             <a:r>
@@ -4121,7 +4109,7 @@
             <a:prstDash val="solid"/>
           </a:ln>
           <a:effectLst>
-            <a:outerShdw sx="100000" sy="100000" kx="0" ky="0" algn="bl" rotWithShape="0" blurRad="101600" dist="12700" dir="5400000">
+            <a:outerShdw blurRad="101600" dist="12700" dir="5400000" sx="100000" sy="100000" kx="0" ky="0" algn="bl" rotWithShape="0">
               <a:srgbClr val="000000">
                 <a:alpha val="8000"/>
               </a:srgbClr>
@@ -4150,7 +4138,7 @@
           <a:bodyPr wrap="square" lIns="0" tIns="0" rIns="0" bIns="0" rtlCol="0" anchor="ctr"/>
           <a:lstStyle/>
           <a:p>
-            <a:pPr indent="0" marL="0">
+            <a:pPr marL="0" indent="0">
               <a:buNone/>
             </a:pPr>
             <a:r>
@@ -4189,7 +4177,7 @@
           <a:bodyPr wrap="square" lIns="0" tIns="0" rIns="0" bIns="0" rtlCol="0" anchor="ctr"/>
           <a:lstStyle/>
           <a:p>
-            <a:pPr indent="0" marL="0">
+            <a:pPr marL="0" indent="0">
               <a:buNone/>
             </a:pPr>
             <a:r>
@@ -4260,11 +4248,11 @@
           <a:bodyPr wrap="square" lIns="0" tIns="0" rIns="0" bIns="0" rtlCol="0" anchor="ctr"/>
           <a:lstStyle/>
           <a:p>
-            <a:pPr indent="0" marL="0">
-              <a:buNone/>
-            </a:pPr>
-            <a:r>
-              <a:rPr lang="en-US" sz="1200" b="1" spc="200" kern="0" dirty="0">
+            <a:pPr marL="0" indent="0">
+              <a:buNone/>
+            </a:pPr>
+            <a:r>
+              <a:rPr lang="en-US" sz="1200" b="1" kern="0" spc="200" dirty="0">
                 <a:solidFill>
                   <a:srgbClr val="5A5F73"/>
                 </a:solidFill>
@@ -4299,7 +4287,7 @@
           <a:bodyPr wrap="square" lIns="0" tIns="0" rIns="0" bIns="0" rtlCol="0" anchor="ctr"/>
           <a:lstStyle/>
           <a:p>
-            <a:pPr indent="0" marL="0">
+            <a:pPr marL="0" indent="0">
               <a:buNone/>
             </a:pPr>
             <a:r>
@@ -4343,7 +4331,7 @@
             <a:prstDash val="solid"/>
           </a:ln>
           <a:effectLst>
-            <a:outerShdw sx="100000" sy="100000" kx="0" ky="0" algn="bl" rotWithShape="0" blurRad="101600" dist="12700" dir="5400000">
+            <a:outerShdw blurRad="101600" dist="12700" dir="5400000" sx="100000" sy="100000" kx="0" ky="0" algn="bl" rotWithShape="0">
               <a:srgbClr val="000000">
                 <a:alpha val="8000"/>
               </a:srgbClr>
@@ -4372,7 +4360,7 @@
           <a:bodyPr wrap="square" lIns="0" tIns="0" rIns="0" bIns="0" rtlCol="0" anchor="ctr"/>
           <a:lstStyle/>
           <a:p>
-            <a:pPr indent="0" marL="0">
+            <a:pPr marL="0" indent="0">
               <a:buNone/>
             </a:pPr>
             <a:r>
@@ -4411,7 +4399,7 @@
           <a:bodyPr wrap="square" lIns="0" tIns="0" rIns="0" bIns="0" rtlCol="0" anchor="ctr"/>
           <a:lstStyle/>
           <a:p>
-            <a:pPr indent="0" marL="0">
+            <a:pPr marL="0" indent="0">
               <a:buNone/>
             </a:pPr>
             <a:r>
@@ -4450,7 +4438,7 @@
           <a:bodyPr wrap="square" lIns="0" tIns="0" rIns="0" bIns="0" rtlCol="0" anchor="ctr"/>
           <a:lstStyle/>
           <a:p>
-            <a:pPr indent="0" marL="0">
+            <a:pPr marL="0" indent="0">
               <a:buNone/>
             </a:pPr>
             <a:r>
@@ -4494,7 +4482,7 @@
             <a:prstDash val="solid"/>
           </a:ln>
           <a:effectLst>
-            <a:outerShdw sx="100000" sy="100000" kx="0" ky="0" algn="bl" rotWithShape="0" blurRad="101600" dist="12700" dir="5400000">
+            <a:outerShdw blurRad="101600" dist="12700" dir="5400000" sx="100000" sy="100000" kx="0" ky="0" algn="bl" rotWithShape="0">
               <a:srgbClr val="000000">
                 <a:alpha val="8000"/>
               </a:srgbClr>
@@ -4523,7 +4511,7 @@
           <a:bodyPr wrap="square" lIns="0" tIns="0" rIns="0" bIns="0" rtlCol="0" anchor="ctr"/>
           <a:lstStyle/>
           <a:p>
-            <a:pPr indent="0" marL="0">
+            <a:pPr marL="0" indent="0">
               <a:buNone/>
             </a:pPr>
             <a:r>
@@ -4562,7 +4550,7 @@
           <a:bodyPr wrap="square" lIns="0" tIns="0" rIns="0" bIns="0" rtlCol="0" anchor="ctr"/>
           <a:lstStyle/>
           <a:p>
-            <a:pPr indent="0" marL="0">
+            <a:pPr marL="0" indent="0">
               <a:buNone/>
             </a:pPr>
             <a:r>
@@ -4601,7 +4589,7 @@
           <a:bodyPr wrap="square" lIns="0" tIns="0" rIns="0" bIns="0" rtlCol="0" anchor="ctr"/>
           <a:lstStyle/>
           <a:p>
-            <a:pPr indent="0" marL="0">
+            <a:pPr marL="0" indent="0">
               <a:buNone/>
             </a:pPr>
             <a:r>
@@ -4645,7 +4633,7 @@
             <a:prstDash val="solid"/>
           </a:ln>
           <a:effectLst>
-            <a:outerShdw sx="100000" sy="100000" kx="0" ky="0" algn="bl" rotWithShape="0" blurRad="101600" dist="12700" dir="5400000">
+            <a:outerShdw blurRad="101600" dist="12700" dir="5400000" sx="100000" sy="100000" kx="0" ky="0" algn="bl" rotWithShape="0">
               <a:srgbClr val="000000">
                 <a:alpha val="8000"/>
               </a:srgbClr>
@@ -4674,7 +4662,7 @@
           <a:bodyPr wrap="square" lIns="0" tIns="0" rIns="0" bIns="0" rtlCol="0" anchor="ctr"/>
           <a:lstStyle/>
           <a:p>
-            <a:pPr indent="0" marL="0">
+            <a:pPr marL="0" indent="0">
               <a:buNone/>
             </a:pPr>
             <a:r>
@@ -4713,7 +4701,7 @@
           <a:bodyPr wrap="square" lIns="0" tIns="0" rIns="0" bIns="0" rtlCol="0" anchor="ctr"/>
           <a:lstStyle/>
           <a:p>
-            <a:pPr indent="0" marL="0">
+            <a:pPr marL="0" indent="0">
               <a:buNone/>
             </a:pPr>
             <a:r>
@@ -4752,7 +4740,7 @@
           <a:bodyPr wrap="square" lIns="0" tIns="0" rIns="0" bIns="0" rtlCol="0" anchor="ctr"/>
           <a:lstStyle/>
           <a:p>
-            <a:pPr indent="0" marL="0">
+            <a:pPr marL="0" indent="0">
               <a:buNone/>
             </a:pPr>
             <a:r>
@@ -4796,7 +4784,7 @@
             <a:prstDash val="solid"/>
           </a:ln>
           <a:effectLst>
-            <a:outerShdw sx="100000" sy="100000" kx="0" ky="0" algn="bl" rotWithShape="0" blurRad="101600" dist="12700" dir="5400000">
+            <a:outerShdw blurRad="101600" dist="12700" dir="5400000" sx="100000" sy="100000" kx="0" ky="0" algn="bl" rotWithShape="0">
               <a:srgbClr val="000000">
                 <a:alpha val="8000"/>
               </a:srgbClr>
@@ -4825,7 +4813,7 @@
           <a:bodyPr wrap="square" lIns="0" tIns="0" rIns="0" bIns="0" rtlCol="0" anchor="ctr"/>
           <a:lstStyle/>
           <a:p>
-            <a:pPr indent="0" marL="0">
+            <a:pPr marL="0" indent="0">
               <a:buNone/>
             </a:pPr>
             <a:r>
@@ -4937,7 +4925,7 @@
 </file>
 
 <file path=ppt/slides/slide12.xml><?xml version="1.0" encoding="utf-8"?>
-<p:sld xmlns:a="http://schemas.openxmlformats.org/drawingml/2006/main" xmlns:r="http://schemas.openxmlformats.org/officeDocument/2006/relationships" xmlns:p="http://schemas.openxmlformats.org/presentationml/2006/main">
+<p:sld xmlns:c="http://schemas.openxmlformats.org/drawingml/2006/chart" xmlns:a="http://schemas.openxmlformats.org/drawingml/2006/main" xmlns:r="http://schemas.openxmlformats.org/officeDocument/2006/relationships" xmlns:p="http://schemas.openxmlformats.org/presentationml/2006/main">
   <p:cSld name="Slide 12">
     <p:bg>
       <p:bgPr>
@@ -4981,11 +4969,11 @@
           <a:bodyPr wrap="square" lIns="0" tIns="0" rIns="0" bIns="0" rtlCol="0" anchor="ctr"/>
           <a:lstStyle/>
           <a:p>
-            <a:pPr indent="0" marL="0">
-              <a:buNone/>
-            </a:pPr>
-            <a:r>
-              <a:rPr lang="en-US" sz="1200" b="1" spc="200" kern="0" dirty="0">
+            <a:pPr marL="0" indent="0">
+              <a:buNone/>
+            </a:pPr>
+            <a:r>
+              <a:rPr lang="en-US" sz="1200" b="1" kern="0" spc="200" dirty="0">
                 <a:solidFill>
                   <a:srgbClr val="5A5F73"/>
                 </a:solidFill>
@@ -5020,7 +5008,7 @@
           <a:bodyPr wrap="square" lIns="0" tIns="0" rIns="0" bIns="0" rtlCol="0" anchor="ctr"/>
           <a:lstStyle/>
           <a:p>
-            <a:pPr indent="0" marL="0">
+            <a:pPr marL="0" indent="0">
               <a:buNone/>
             </a:pPr>
             <a:r>
@@ -5075,7 +5063,7 @@
           <a:bodyPr wrap="square" lIns="0" tIns="0" rIns="0" bIns="0" rtlCol="0" anchor="ctr"/>
           <a:lstStyle/>
           <a:p>
-            <a:pPr indent="0" marL="0">
+            <a:pPr marL="0" indent="0">
               <a:buNone/>
             </a:pPr>
             <a:r>
@@ -5114,7 +5102,7 @@
           <a:bodyPr wrap="square" lIns="0" tIns="0" rIns="0" bIns="0" rtlCol="0" anchor="ctr"/>
           <a:lstStyle/>
           <a:p>
-            <a:pPr indent="0" marL="0">
+            <a:pPr marL="0" indent="0">
               <a:buNone/>
             </a:pPr>
             <a:r>
@@ -5153,7 +5141,7 @@
           <a:bodyPr wrap="square" lIns="0" tIns="0" rIns="0" bIns="0" rtlCol="0" anchor="ctr"/>
           <a:lstStyle/>
           <a:p>
-            <a:pPr indent="0" marL="0">
+            <a:pPr marL="0" indent="0">
               <a:buNone/>
             </a:pPr>
             <a:r>
@@ -5192,7 +5180,7 @@
           <a:bodyPr wrap="square" lIns="0" tIns="0" rIns="0" bIns="0" rtlCol="0" anchor="ctr"/>
           <a:lstStyle/>
           <a:p>
-            <a:pPr indent="0" marL="0">
+            <a:pPr marL="0" indent="0">
               <a:buNone/>
             </a:pPr>
             <a:r>
@@ -5231,7 +5219,7 @@
           <a:bodyPr wrap="square" lIns="0" tIns="0" rIns="0" bIns="0" rtlCol="0" anchor="ctr"/>
           <a:lstStyle/>
           <a:p>
-            <a:pPr indent="0" marL="0">
+            <a:pPr marL="0" indent="0">
               <a:buNone/>
             </a:pPr>
             <a:r>
@@ -5270,7 +5258,7 @@
           <a:bodyPr wrap="square" lIns="0" tIns="0" rIns="0" bIns="0" rtlCol="0" anchor="ctr"/>
           <a:lstStyle/>
           <a:p>
-            <a:pPr indent="0" marL="0">
+            <a:pPr marL="0" indent="0">
               <a:buNone/>
             </a:pPr>
             <a:r>
@@ -5309,7 +5297,7 @@
           <a:bodyPr wrap="square" lIns="0" tIns="0" rIns="0" bIns="0" rtlCol="0" anchor="ctr"/>
           <a:lstStyle/>
           <a:p>
-            <a:pPr indent="0" marL="0">
+            <a:pPr marL="0" indent="0">
               <a:buNone/>
             </a:pPr>
             <a:r>
@@ -5348,7 +5336,7 @@
           <a:bodyPr wrap="square" lIns="0" tIns="0" rIns="0" bIns="0" rtlCol="0" anchor="ctr"/>
           <a:lstStyle/>
           <a:p>
-            <a:pPr indent="0" marL="0">
+            <a:pPr marL="0" indent="0">
               <a:buNone/>
             </a:pPr>
             <a:r>
@@ -5419,11 +5407,11 @@
           <a:bodyPr wrap="square" lIns="0" tIns="0" rIns="0" bIns="0" rtlCol="0" anchor="ctr"/>
           <a:lstStyle/>
           <a:p>
-            <a:pPr indent="0" marL="0">
-              <a:buNone/>
-            </a:pPr>
-            <a:r>
-              <a:rPr lang="en-US" sz="1200" b="1" spc="200" kern="0" dirty="0">
+            <a:pPr marL="0" indent="0">
+              <a:buNone/>
+            </a:pPr>
+            <a:r>
+              <a:rPr lang="en-US" sz="1200" b="1" kern="0" spc="200" dirty="0">
                 <a:solidFill>
                   <a:srgbClr val="5A5F73"/>
                 </a:solidFill>
@@ -5458,7 +5446,7 @@
           <a:bodyPr wrap="square" lIns="0" tIns="0" rIns="0" bIns="0" rtlCol="0" anchor="ctr"/>
           <a:lstStyle/>
           <a:p>
-            <a:pPr indent="0" marL="0">
+            <a:pPr marL="0" indent="0">
               <a:buNone/>
             </a:pPr>
             <a:r>
@@ -5478,7 +5466,7 @@
       </p:sp>
       <p:pic>
         <p:nvPicPr>
-          <p:cNvPr id="4" name="Image 0" descr="preencoded.png">    </p:cNvPr>
+          <p:cNvPr id="4" name="Image 0" descr="preencoded.png"/>
           <p:cNvPicPr>
             <a:picLocks noChangeAspect="1"/>
           </p:cNvPicPr>
@@ -5526,7 +5514,7 @@
             <a:prstDash val="solid"/>
           </a:ln>
           <a:effectLst>
-            <a:outerShdw sx="100000" sy="100000" kx="0" ky="0" algn="bl" rotWithShape="0" blurRad="101600" dist="12700" dir="5400000">
+            <a:outerShdw blurRad="101600" dist="12700" dir="5400000" sx="100000" sy="100000" kx="0" ky="0" algn="bl" rotWithShape="0">
               <a:srgbClr val="000000">
                 <a:alpha val="8000"/>
               </a:srgbClr>
@@ -5555,7 +5543,7 @@
           <a:bodyPr wrap="square" lIns="0" tIns="0" rIns="0" bIns="0" rtlCol="0" anchor="ctr"/>
           <a:lstStyle/>
           <a:p>
-            <a:pPr indent="0" marL="0">
+            <a:pPr marL="0" indent="0">
               <a:buNone/>
             </a:pPr>
             <a:r>
@@ -5594,7 +5582,7 @@
           <a:bodyPr wrap="square" lIns="0" tIns="0" rIns="0" bIns="0" rtlCol="0" anchor="ctr"/>
           <a:lstStyle/>
           <a:p>
-            <a:pPr indent="0" marL="0">
+            <a:pPr marL="0" indent="0">
               <a:buNone/>
             </a:pPr>
             <a:r>
@@ -5638,7 +5626,7 @@
             <a:prstDash val="solid"/>
           </a:ln>
           <a:effectLst>
-            <a:outerShdw sx="100000" sy="100000" kx="0" ky="0" algn="bl" rotWithShape="0" blurRad="101600" dist="12700" dir="5400000">
+            <a:outerShdw blurRad="101600" dist="12700" dir="5400000" sx="100000" sy="100000" kx="0" ky="0" algn="bl" rotWithShape="0">
               <a:srgbClr val="000000">
                 <a:alpha val="8000"/>
               </a:srgbClr>
@@ -5667,7 +5655,7 @@
           <a:bodyPr wrap="square" lIns="0" tIns="0" rIns="0" bIns="0" rtlCol="0" anchor="ctr"/>
           <a:lstStyle/>
           <a:p>
-            <a:pPr indent="0" marL="0">
+            <a:pPr marL="0" indent="0">
               <a:buNone/>
             </a:pPr>
             <a:r>
@@ -5706,7 +5694,7 @@
           <a:bodyPr wrap="square" lIns="0" tIns="0" rIns="0" bIns="0" rtlCol="0" anchor="ctr"/>
           <a:lstStyle/>
           <a:p>
-            <a:pPr indent="0" marL="0">
+            <a:pPr marL="0" indent="0">
               <a:buNone/>
             </a:pPr>
             <a:r>
@@ -5750,7 +5738,7 @@
             <a:prstDash val="solid"/>
           </a:ln>
           <a:effectLst>
-            <a:outerShdw sx="100000" sy="100000" kx="0" ky="0" algn="bl" rotWithShape="0" blurRad="101600" dist="12700" dir="5400000">
+            <a:outerShdw blurRad="101600" dist="12700" dir="5400000" sx="100000" sy="100000" kx="0" ky="0" algn="bl" rotWithShape="0">
               <a:srgbClr val="000000">
                 <a:alpha val="8000"/>
               </a:srgbClr>
@@ -5779,7 +5767,7 @@
           <a:bodyPr wrap="square" lIns="0" tIns="0" rIns="0" bIns="0" rtlCol="0" anchor="ctr"/>
           <a:lstStyle/>
           <a:p>
-            <a:pPr indent="0" marL="0">
+            <a:pPr marL="0" indent="0">
               <a:buNone/>
             </a:pPr>
             <a:r>
@@ -5818,7 +5806,7 @@
           <a:bodyPr wrap="square" lIns="0" tIns="0" rIns="0" bIns="0" rtlCol="0" anchor="ctr"/>
           <a:lstStyle/>
           <a:p>
-            <a:pPr indent="0" marL="0">
+            <a:pPr marL="0" indent="0">
               <a:buNone/>
             </a:pPr>
             <a:r>
@@ -5889,11 +5877,11 @@
           <a:bodyPr wrap="square" lIns="0" tIns="0" rIns="0" bIns="0" rtlCol="0" anchor="ctr"/>
           <a:lstStyle/>
           <a:p>
-            <a:pPr indent="0" marL="0">
-              <a:buNone/>
-            </a:pPr>
-            <a:r>
-              <a:rPr lang="en-US" sz="1200" b="1" spc="200" kern="0" dirty="0">
+            <a:pPr marL="0" indent="0">
+              <a:buNone/>
+            </a:pPr>
+            <a:r>
+              <a:rPr lang="en-US" sz="1200" b="1" kern="0" spc="200" dirty="0">
                 <a:solidFill>
                   <a:srgbClr val="5A5F73"/>
                 </a:solidFill>
@@ -5928,7 +5916,7 @@
           <a:bodyPr wrap="square" lIns="0" tIns="0" rIns="0" bIns="0" rtlCol="0" anchor="ctr"/>
           <a:lstStyle/>
           <a:p>
-            <a:pPr indent="0" marL="0">
+            <a:pPr marL="0" indent="0">
               <a:buNone/>
             </a:pPr>
             <a:r>
@@ -5994,7 +5982,7 @@
           <a:bodyPr wrap="square" lIns="0" tIns="0" rIns="0" bIns="0" rtlCol="0" anchor="ctr"/>
           <a:lstStyle/>
           <a:p>
-            <a:pPr algn="ctr" indent="0" marL="0">
+            <a:pPr marL="0" indent="0" algn="ctr">
               <a:buNone/>
             </a:pPr>
             <a:r>
@@ -6033,7 +6021,7 @@
           <a:bodyPr wrap="square" lIns="0" tIns="0" rIns="0" bIns="0" rtlCol="0" anchor="ctr"/>
           <a:lstStyle/>
           <a:p>
-            <a:pPr indent="0" marL="0">
+            <a:pPr marL="0" indent="0">
               <a:buNone/>
             </a:pPr>
             <a:r>
@@ -6072,7 +6060,7 @@
           <a:bodyPr wrap="square" lIns="0" tIns="0" rIns="0" bIns="0" rtlCol="0" anchor="ctr"/>
           <a:lstStyle/>
           <a:p>
-            <a:pPr indent="0" marL="0">
+            <a:pPr marL="0" indent="0">
               <a:buNone/>
             </a:pPr>
             <a:r>
@@ -6138,7 +6126,7 @@
           <a:bodyPr wrap="square" lIns="0" tIns="0" rIns="0" bIns="0" rtlCol="0" anchor="ctr"/>
           <a:lstStyle/>
           <a:p>
-            <a:pPr algn="ctr" indent="0" marL="0">
+            <a:pPr marL="0" indent="0" algn="ctr">
               <a:buNone/>
             </a:pPr>
             <a:r>
@@ -6177,7 +6165,7 @@
           <a:bodyPr wrap="square" lIns="0" tIns="0" rIns="0" bIns="0" rtlCol="0" anchor="ctr"/>
           <a:lstStyle/>
           <a:p>
-            <a:pPr indent="0" marL="0">
+            <a:pPr marL="0" indent="0">
               <a:buNone/>
             </a:pPr>
             <a:r>
@@ -6216,7 +6204,7 @@
           <a:bodyPr wrap="square" lIns="0" tIns="0" rIns="0" bIns="0" rtlCol="0" anchor="ctr"/>
           <a:lstStyle/>
           <a:p>
-            <a:pPr indent="0" marL="0">
+            <a:pPr marL="0" indent="0">
               <a:buNone/>
             </a:pPr>
             <a:r>
@@ -6282,7 +6270,7 @@
           <a:bodyPr wrap="square" lIns="0" tIns="0" rIns="0" bIns="0" rtlCol="0" anchor="ctr"/>
           <a:lstStyle/>
           <a:p>
-            <a:pPr algn="ctr" indent="0" marL="0">
+            <a:pPr marL="0" indent="0" algn="ctr">
               <a:buNone/>
             </a:pPr>
             <a:r>
@@ -6321,7 +6309,7 @@
           <a:bodyPr wrap="square" lIns="0" tIns="0" rIns="0" bIns="0" rtlCol="0" anchor="ctr"/>
           <a:lstStyle/>
           <a:p>
-            <a:pPr indent="0" marL="0">
+            <a:pPr marL="0" indent="0">
               <a:buNone/>
             </a:pPr>
             <a:r>
@@ -6360,7 +6348,7 @@
           <a:bodyPr wrap="square" lIns="0" tIns="0" rIns="0" bIns="0" rtlCol="0" anchor="ctr"/>
           <a:lstStyle/>
           <a:p>
-            <a:pPr indent="0" marL="0">
+            <a:pPr marL="0" indent="0">
               <a:buNone/>
             </a:pPr>
             <a:r>
@@ -6426,7 +6414,7 @@
           <a:bodyPr wrap="square" lIns="0" tIns="0" rIns="0" bIns="0" rtlCol="0" anchor="ctr"/>
           <a:lstStyle/>
           <a:p>
-            <a:pPr algn="ctr" indent="0" marL="0">
+            <a:pPr marL="0" indent="0" algn="ctr">
               <a:buNone/>
             </a:pPr>
             <a:r>
@@ -6465,7 +6453,7 @@
           <a:bodyPr wrap="square" lIns="0" tIns="0" rIns="0" bIns="0" rtlCol="0" anchor="ctr"/>
           <a:lstStyle/>
           <a:p>
-            <a:pPr indent="0" marL="0">
+            <a:pPr marL="0" indent="0">
               <a:buNone/>
             </a:pPr>
             <a:r>
@@ -6504,7 +6492,7 @@
           <a:bodyPr wrap="square" lIns="0" tIns="0" rIns="0" bIns="0" rtlCol="0" anchor="ctr"/>
           <a:lstStyle/>
           <a:p>
-            <a:pPr indent="0" marL="0">
+            <a:pPr marL="0" indent="0">
               <a:buNone/>
             </a:pPr>
             <a:r>
@@ -6570,7 +6558,7 @@
           <a:bodyPr wrap="square" lIns="0" tIns="0" rIns="0" bIns="0" rtlCol="0" anchor="ctr"/>
           <a:lstStyle/>
           <a:p>
-            <a:pPr algn="ctr" indent="0" marL="0">
+            <a:pPr marL="0" indent="0" algn="ctr">
               <a:buNone/>
             </a:pPr>
             <a:r>
@@ -6609,7 +6597,7 @@
           <a:bodyPr wrap="square" lIns="0" tIns="0" rIns="0" bIns="0" rtlCol="0" anchor="ctr"/>
           <a:lstStyle/>
           <a:p>
-            <a:pPr indent="0" marL="0">
+            <a:pPr marL="0" indent="0">
               <a:buNone/>
             </a:pPr>
             <a:r>
@@ -6648,7 +6636,7 @@
           <a:bodyPr wrap="square" lIns="0" tIns="0" rIns="0" bIns="0" rtlCol="0" anchor="ctr"/>
           <a:lstStyle/>
           <a:p>
-            <a:pPr indent="0" marL="0">
+            <a:pPr marL="0" indent="0">
               <a:buNone/>
             </a:pPr>
             <a:r>
@@ -6714,7 +6702,7 @@
           <a:bodyPr wrap="square" lIns="0" tIns="0" rIns="0" bIns="0" rtlCol="0" anchor="ctr"/>
           <a:lstStyle/>
           <a:p>
-            <a:pPr algn="ctr" indent="0" marL="0">
+            <a:pPr marL="0" indent="0" algn="ctr">
               <a:buNone/>
             </a:pPr>
             <a:r>
@@ -6753,7 +6741,7 @@
           <a:bodyPr wrap="square" lIns="0" tIns="0" rIns="0" bIns="0" rtlCol="0" anchor="ctr"/>
           <a:lstStyle/>
           <a:p>
-            <a:pPr indent="0" marL="0">
+            <a:pPr marL="0" indent="0">
               <a:buNone/>
             </a:pPr>
             <a:r>
@@ -6792,7 +6780,7 @@
           <a:bodyPr wrap="square" lIns="0" tIns="0" rIns="0" bIns="0" rtlCol="0" anchor="ctr"/>
           <a:lstStyle/>
           <a:p>
-            <a:pPr indent="0" marL="0">
+            <a:pPr marL="0" indent="0">
               <a:buNone/>
             </a:pPr>
             <a:r>
@@ -6858,7 +6846,7 @@
           <a:bodyPr wrap="square" lIns="0" tIns="0" rIns="0" bIns="0" rtlCol="0" anchor="ctr"/>
           <a:lstStyle/>
           <a:p>
-            <a:pPr algn="ctr" indent="0" marL="0">
+            <a:pPr marL="0" indent="0" algn="ctr">
               <a:buNone/>
             </a:pPr>
             <a:r>
@@ -6897,7 +6885,7 @@
           <a:bodyPr wrap="square" lIns="0" tIns="0" rIns="0" bIns="0" rtlCol="0" anchor="ctr"/>
           <a:lstStyle/>
           <a:p>
-            <a:pPr indent="0" marL="0">
+            <a:pPr marL="0" indent="0">
               <a:buNone/>
             </a:pPr>
             <a:r>
@@ -6936,7 +6924,7 @@
           <a:bodyPr wrap="square" lIns="0" tIns="0" rIns="0" bIns="0" rtlCol="0" anchor="ctr"/>
           <a:lstStyle/>
           <a:p>
-            <a:pPr indent="0" marL="0">
+            <a:pPr marL="0" indent="0">
               <a:buNone/>
             </a:pPr>
             <a:r>
@@ -6975,7 +6963,7 @@
           <a:bodyPr wrap="square" lIns="0" tIns="0" rIns="0" bIns="0" rtlCol="0" anchor="ctr"/>
           <a:lstStyle/>
           <a:p>
-            <a:pPr indent="0" marL="0">
+            <a:pPr marL="0" indent="0">
               <a:buNone/>
             </a:pPr>
             <a:r>
@@ -7046,11 +7034,11 @@
           <a:bodyPr wrap="square" lIns="0" tIns="0" rIns="0" bIns="0" rtlCol="0" anchor="ctr"/>
           <a:lstStyle/>
           <a:p>
-            <a:pPr indent="0" marL="0">
-              <a:buNone/>
-            </a:pPr>
-            <a:r>
-              <a:rPr lang="en-US" sz="1200" b="1" spc="200" kern="0" dirty="0">
+            <a:pPr marL="0" indent="0">
+              <a:buNone/>
+            </a:pPr>
+            <a:r>
+              <a:rPr lang="en-US" sz="1200" b="1" kern="0" spc="200" dirty="0">
                 <a:solidFill>
                   <a:srgbClr val="5A5F73"/>
                 </a:solidFill>
@@ -7085,7 +7073,7 @@
           <a:bodyPr wrap="square" lIns="0" tIns="0" rIns="0" bIns="0" rtlCol="0" anchor="ctr"/>
           <a:lstStyle/>
           <a:p>
-            <a:pPr indent="0" marL="0">
+            <a:pPr marL="0" indent="0">
               <a:buNone/>
             </a:pPr>
             <a:r>
@@ -7129,7 +7117,7 @@
             <a:prstDash val="solid"/>
           </a:ln>
           <a:effectLst>
-            <a:outerShdw sx="100000" sy="100000" kx="0" ky="0" algn="bl" rotWithShape="0" blurRad="101600" dist="12700" dir="5400000">
+            <a:outerShdw blurRad="101600" dist="12700" dir="5400000" sx="100000" sy="100000" kx="0" ky="0" algn="bl" rotWithShape="0">
               <a:srgbClr val="000000">
                 <a:alpha val="8000"/>
               </a:srgbClr>
@@ -7158,7 +7146,7 @@
           <a:bodyPr wrap="square" lIns="0" tIns="0" rIns="0" bIns="0" rtlCol="0" anchor="ctr"/>
           <a:lstStyle/>
           <a:p>
-            <a:pPr algn="ctr" indent="0" marL="0">
+            <a:pPr marL="0" indent="0" algn="ctr">
               <a:buNone/>
             </a:pPr>
             <a:r>
@@ -7197,7 +7185,7 @@
           <a:bodyPr wrap="square" lIns="0" tIns="0" rIns="0" bIns="0" rtlCol="0" anchor="ctr"/>
           <a:lstStyle/>
           <a:p>
-            <a:pPr algn="ctr" indent="0" marL="0">
+            <a:pPr marL="0" indent="0" algn="ctr">
               <a:buNone/>
             </a:pPr>
             <a:r>
@@ -7241,7 +7229,7 @@
             <a:prstDash val="solid"/>
           </a:ln>
           <a:effectLst>
-            <a:outerShdw sx="100000" sy="100000" kx="0" ky="0" algn="bl" rotWithShape="0" blurRad="101600" dist="12700" dir="5400000">
+            <a:outerShdw blurRad="101600" dist="12700" dir="5400000" sx="100000" sy="100000" kx="0" ky="0" algn="bl" rotWithShape="0">
               <a:srgbClr val="000000">
                 <a:alpha val="8000"/>
               </a:srgbClr>
@@ -7270,7 +7258,7 @@
           <a:bodyPr wrap="square" lIns="0" tIns="0" rIns="0" bIns="0" rtlCol="0" anchor="ctr"/>
           <a:lstStyle/>
           <a:p>
-            <a:pPr algn="ctr" indent="0" marL="0">
+            <a:pPr marL="0" indent="0" algn="ctr">
               <a:buNone/>
             </a:pPr>
             <a:r>
@@ -7309,7 +7297,7 @@
           <a:bodyPr wrap="square" lIns="0" tIns="0" rIns="0" bIns="0" rtlCol="0" anchor="ctr"/>
           <a:lstStyle/>
           <a:p>
-            <a:pPr algn="ctr" indent="0" marL="0">
+            <a:pPr marL="0" indent="0" algn="ctr">
               <a:buNone/>
             </a:pPr>
             <a:r>
@@ -7353,7 +7341,7 @@
             <a:prstDash val="solid"/>
           </a:ln>
           <a:effectLst>
-            <a:outerShdw sx="100000" sy="100000" kx="0" ky="0" algn="bl" rotWithShape="0" blurRad="101600" dist="12700" dir="5400000">
+            <a:outerShdw blurRad="101600" dist="12700" dir="5400000" sx="100000" sy="100000" kx="0" ky="0" algn="bl" rotWithShape="0">
               <a:srgbClr val="000000">
                 <a:alpha val="8000"/>
               </a:srgbClr>
@@ -7382,7 +7370,7 @@
           <a:bodyPr wrap="square" lIns="0" tIns="0" rIns="0" bIns="0" rtlCol="0" anchor="ctr"/>
           <a:lstStyle/>
           <a:p>
-            <a:pPr algn="ctr" indent="0" marL="0">
+            <a:pPr marL="0" indent="0" algn="ctr">
               <a:buNone/>
             </a:pPr>
             <a:r>
@@ -7421,7 +7409,7 @@
           <a:bodyPr wrap="square" lIns="0" tIns="0" rIns="0" bIns="0" rtlCol="0" anchor="ctr"/>
           <a:lstStyle/>
           <a:p>
-            <a:pPr algn="ctr" indent="0" marL="0">
+            <a:pPr marL="0" indent="0" algn="ctr">
               <a:buNone/>
             </a:pPr>
             <a:r>
@@ -7465,7 +7453,7 @@
             <a:prstDash val="solid"/>
           </a:ln>
           <a:effectLst>
-            <a:outerShdw sx="100000" sy="100000" kx="0" ky="0" algn="bl" rotWithShape="0" blurRad="101600" dist="12700" dir="5400000">
+            <a:outerShdw blurRad="101600" dist="12700" dir="5400000" sx="100000" sy="100000" kx="0" ky="0" algn="bl" rotWithShape="0">
               <a:srgbClr val="000000">
                 <a:alpha val="8000"/>
               </a:srgbClr>
@@ -7494,7 +7482,7 @@
           <a:bodyPr wrap="square" lIns="0" tIns="0" rIns="0" bIns="0" rtlCol="0" anchor="ctr"/>
           <a:lstStyle/>
           <a:p>
-            <a:pPr algn="ctr" indent="0" marL="0">
+            <a:pPr marL="0" indent="0" algn="ctr">
               <a:buNone/>
             </a:pPr>
             <a:r>
@@ -7533,7 +7521,7 @@
           <a:bodyPr wrap="square" lIns="0" tIns="0" rIns="0" bIns="0" rtlCol="0" anchor="ctr"/>
           <a:lstStyle/>
           <a:p>
-            <a:pPr algn="ctr" indent="0" marL="0">
+            <a:pPr marL="0" indent="0" algn="ctr">
               <a:buNone/>
             </a:pPr>
             <a:r>
@@ -7572,7 +7560,7 @@
           <a:bodyPr wrap="square" lIns="0" tIns="0" rIns="0" bIns="0" rtlCol="0" anchor="ctr"/>
           <a:lstStyle/>
           <a:p>
-            <a:pPr indent="0" marL="0">
+            <a:pPr marL="0" indent="0">
               <a:buNone/>
             </a:pPr>
             <a:r>
@@ -7728,11 +7716,11 @@
           <a:bodyPr wrap="square" lIns="0" tIns="0" rIns="0" bIns="0" rtlCol="0" anchor="ctr"/>
           <a:lstStyle/>
           <a:p>
-            <a:pPr indent="0" marL="0">
-              <a:buNone/>
-            </a:pPr>
-            <a:r>
-              <a:rPr lang="en-US" sz="1200" b="1" spc="200" kern="0" dirty="0">
+            <a:pPr marL="0" indent="0">
+              <a:buNone/>
+            </a:pPr>
+            <a:r>
+              <a:rPr lang="en-US" sz="1200" b="1" kern="0" spc="200" dirty="0">
                 <a:solidFill>
                   <a:srgbClr val="5A5F73"/>
                 </a:solidFill>
@@ -7767,7 +7755,7 @@
           <a:bodyPr wrap="square" lIns="0" tIns="0" rIns="0" bIns="0" rtlCol="0" anchor="ctr"/>
           <a:lstStyle/>
           <a:p>
-            <a:pPr indent="0" marL="0">
+            <a:pPr marL="0" indent="0">
               <a:buNone/>
             </a:pPr>
             <a:r>
@@ -7811,7 +7799,7 @@
             <a:prstDash val="solid"/>
           </a:ln>
           <a:effectLst>
-            <a:outerShdw sx="100000" sy="100000" kx="0" ky="0" algn="bl" rotWithShape="0" blurRad="101600" dist="12700" dir="5400000">
+            <a:outerShdw blurRad="101600" dist="12700" dir="5400000" sx="100000" sy="100000" kx="0" ky="0" algn="bl" rotWithShape="0">
               <a:srgbClr val="000000">
                 <a:alpha val="8000"/>
               </a:srgbClr>
@@ -7840,7 +7828,7 @@
           <a:bodyPr wrap="square" lIns="0" tIns="0" rIns="0" bIns="0" rtlCol="0" anchor="ctr"/>
           <a:lstStyle/>
           <a:p>
-            <a:pPr indent="0" marL="0">
+            <a:pPr marL="0" indent="0">
               <a:buNone/>
             </a:pPr>
             <a:r>
@@ -7969,7 +7957,7 @@
             <a:prstDash val="solid"/>
           </a:ln>
           <a:effectLst>
-            <a:outerShdw sx="100000" sy="100000" kx="0" ky="0" algn="bl" rotWithShape="0" blurRad="101600" dist="12700" dir="5400000">
+            <a:outerShdw blurRad="101600" dist="12700" dir="5400000" sx="100000" sy="100000" kx="0" ky="0" algn="bl" rotWithShape="0">
               <a:srgbClr val="000000">
                 <a:alpha val="8000"/>
               </a:srgbClr>
@@ -7998,7 +7986,7 @@
           <a:bodyPr wrap="square" lIns="0" tIns="0" rIns="0" bIns="0" rtlCol="0" anchor="ctr"/>
           <a:lstStyle/>
           <a:p>
-            <a:pPr indent="0" marL="0">
+            <a:pPr marL="0" indent="0">
               <a:buNone/>
             </a:pPr>
             <a:r>
@@ -8267,7 +8255,7 @@
           <a:bodyPr wrap="square" lIns="0" tIns="0" rIns="0" bIns="0" rtlCol="0" anchor="ctr"/>
           <a:lstStyle/>
           <a:p>
-            <a:pPr indent="0" marL="0">
+            <a:pPr marL="0" indent="0">
               <a:buNone/>
             </a:pPr>
             <a:r>
@@ -8306,7 +8294,7 @@
           <a:bodyPr wrap="square" lIns="0" tIns="0" rIns="0" bIns="0" rtlCol="0" anchor="ctr"/>
           <a:lstStyle/>
           <a:p>
-            <a:pPr indent="0" marL="0">
+            <a:pPr marL="0" indent="0">
               <a:buNone/>
             </a:pPr>
             <a:r>
@@ -8345,7 +8333,7 @@
           <a:bodyPr wrap="square" lIns="0" tIns="0" rIns="0" bIns="0" rtlCol="0" anchor="ctr"/>
           <a:lstStyle/>
           <a:p>
-            <a:pPr indent="0" marL="0">
+            <a:pPr marL="0" indent="0">
               <a:buNone/>
             </a:pPr>
             <a:r>
@@ -8416,11 +8404,11 @@
           <a:bodyPr wrap="square" lIns="0" tIns="0" rIns="0" bIns="0" rtlCol="0" anchor="ctr"/>
           <a:lstStyle/>
           <a:p>
-            <a:pPr indent="0" marL="0">
-              <a:buNone/>
-            </a:pPr>
-            <a:r>
-              <a:rPr lang="en-US" sz="1200" b="1" spc="200" kern="0" dirty="0">
+            <a:pPr marL="0" indent="0">
+              <a:buNone/>
+            </a:pPr>
+            <a:r>
+              <a:rPr lang="en-US" sz="1200" b="1" kern="0" spc="200" dirty="0">
                 <a:solidFill>
                   <a:srgbClr val="5A5F73"/>
                 </a:solidFill>
@@ -8455,7 +8443,7 @@
           <a:bodyPr wrap="square" lIns="0" tIns="0" rIns="0" bIns="0" rtlCol="0" anchor="ctr"/>
           <a:lstStyle/>
           <a:p>
-            <a:pPr indent="0" marL="0">
+            <a:pPr marL="0" indent="0">
               <a:buNone/>
             </a:pPr>
             <a:r>
@@ -8499,7 +8487,7 @@
             <a:prstDash val="solid"/>
           </a:ln>
           <a:effectLst>
-            <a:outerShdw sx="100000" sy="100000" kx="0" ky="0" algn="bl" rotWithShape="0" blurRad="101600" dist="12700" dir="5400000">
+            <a:outerShdw blurRad="101600" dist="12700" dir="5400000" sx="100000" sy="100000" kx="0" ky="0" algn="bl" rotWithShape="0">
               <a:srgbClr val="000000">
                 <a:alpha val="8000"/>
               </a:srgbClr>
@@ -8553,7 +8541,7 @@
           <a:bodyPr wrap="square" lIns="0" tIns="0" rIns="0" bIns="0" rtlCol="0" anchor="ctr"/>
           <a:lstStyle/>
           <a:p>
-            <a:pPr algn="ctr" indent="0" marL="0">
+            <a:pPr marL="0" indent="0" algn="ctr">
               <a:buNone/>
             </a:pPr>
             <a:r>
@@ -8592,7 +8580,7 @@
           <a:bodyPr wrap="square" lIns="0" tIns="0" rIns="0" bIns="0" rtlCol="0" anchor="ctr"/>
           <a:lstStyle/>
           <a:p>
-            <a:pPr indent="0" marL="0">
+            <a:pPr marL="0" indent="0">
               <a:buNone/>
             </a:pPr>
             <a:r>
@@ -8631,7 +8619,7 @@
           <a:bodyPr wrap="square" lIns="0" tIns="0" rIns="0" bIns="0" rtlCol="0" anchor="ctr"/>
           <a:lstStyle/>
           <a:p>
-            <a:pPr indent="0" marL="0">
+            <a:pPr marL="0" indent="0">
               <a:buNone/>
             </a:pPr>
             <a:r>
@@ -8675,7 +8663,7 @@
             <a:prstDash val="solid"/>
           </a:ln>
           <a:effectLst>
-            <a:outerShdw sx="100000" sy="100000" kx="0" ky="0" algn="bl" rotWithShape="0" blurRad="101600" dist="12700" dir="5400000">
+            <a:outerShdw blurRad="101600" dist="12700" dir="5400000" sx="100000" sy="100000" kx="0" ky="0" algn="bl" rotWithShape="0">
               <a:srgbClr val="000000">
                 <a:alpha val="8000"/>
               </a:srgbClr>
@@ -8729,7 +8717,7 @@
           <a:bodyPr wrap="square" lIns="0" tIns="0" rIns="0" bIns="0" rtlCol="0" anchor="ctr"/>
           <a:lstStyle/>
           <a:p>
-            <a:pPr algn="ctr" indent="0" marL="0">
+            <a:pPr marL="0" indent="0" algn="ctr">
               <a:buNone/>
             </a:pPr>
             <a:r>
@@ -8768,7 +8756,7 @@
           <a:bodyPr wrap="square" lIns="0" tIns="0" rIns="0" bIns="0" rtlCol="0" anchor="ctr"/>
           <a:lstStyle/>
           <a:p>
-            <a:pPr indent="0" marL="0">
+            <a:pPr marL="0" indent="0">
               <a:buNone/>
             </a:pPr>
             <a:r>
@@ -8807,7 +8795,7 @@
           <a:bodyPr wrap="square" lIns="0" tIns="0" rIns="0" bIns="0" rtlCol="0" anchor="ctr"/>
           <a:lstStyle/>
           <a:p>
-            <a:pPr indent="0" marL="0">
+            <a:pPr marL="0" indent="0">
               <a:buNone/>
             </a:pPr>
             <a:r>
@@ -8851,7 +8839,7 @@
             <a:prstDash val="solid"/>
           </a:ln>
           <a:effectLst>
-            <a:outerShdw sx="100000" sy="100000" kx="0" ky="0" algn="bl" rotWithShape="0" blurRad="101600" dist="12700" dir="5400000">
+            <a:outerShdw blurRad="101600" dist="12700" dir="5400000" sx="100000" sy="100000" kx="0" ky="0" algn="bl" rotWithShape="0">
               <a:srgbClr val="000000">
                 <a:alpha val="8000"/>
               </a:srgbClr>
@@ -8905,7 +8893,7 @@
           <a:bodyPr wrap="square" lIns="0" tIns="0" rIns="0" bIns="0" rtlCol="0" anchor="ctr"/>
           <a:lstStyle/>
           <a:p>
-            <a:pPr algn="ctr" indent="0" marL="0">
+            <a:pPr marL="0" indent="0" algn="ctr">
               <a:buNone/>
             </a:pPr>
             <a:r>
@@ -8944,7 +8932,7 @@
           <a:bodyPr wrap="square" lIns="0" tIns="0" rIns="0" bIns="0" rtlCol="0" anchor="ctr"/>
           <a:lstStyle/>
           <a:p>
-            <a:pPr indent="0" marL="0">
+            <a:pPr marL="0" indent="0">
               <a:buNone/>
             </a:pPr>
             <a:r>
@@ -8983,7 +8971,7 @@
           <a:bodyPr wrap="square" lIns="0" tIns="0" rIns="0" bIns="0" rtlCol="0" anchor="ctr"/>
           <a:lstStyle/>
           <a:p>
-            <a:pPr indent="0" marL="0">
+            <a:pPr marL="0" indent="0">
               <a:buNone/>
             </a:pPr>
             <a:r>
@@ -9027,7 +9015,7 @@
             <a:prstDash val="solid"/>
           </a:ln>
           <a:effectLst>
-            <a:outerShdw sx="100000" sy="100000" kx="0" ky="0" algn="bl" rotWithShape="0" blurRad="101600" dist="12700" dir="5400000">
+            <a:outerShdw blurRad="101600" dist="12700" dir="5400000" sx="100000" sy="100000" kx="0" ky="0" algn="bl" rotWithShape="0">
               <a:srgbClr val="000000">
                 <a:alpha val="8000"/>
               </a:srgbClr>
@@ -9081,7 +9069,7 @@
           <a:bodyPr wrap="square" lIns="0" tIns="0" rIns="0" bIns="0" rtlCol="0" anchor="ctr"/>
           <a:lstStyle/>
           <a:p>
-            <a:pPr algn="ctr" indent="0" marL="0">
+            <a:pPr marL="0" indent="0" algn="ctr">
               <a:buNone/>
             </a:pPr>
             <a:r>
@@ -9120,7 +9108,7 @@
           <a:bodyPr wrap="square" lIns="0" tIns="0" rIns="0" bIns="0" rtlCol="0" anchor="ctr"/>
           <a:lstStyle/>
           <a:p>
-            <a:pPr indent="0" marL="0">
+            <a:pPr marL="0" indent="0">
               <a:buNone/>
             </a:pPr>
             <a:r>
@@ -9159,7 +9147,7 @@
           <a:bodyPr wrap="square" lIns="0" tIns="0" rIns="0" bIns="0" rtlCol="0" anchor="ctr"/>
           <a:lstStyle/>
           <a:p>
-            <a:pPr indent="0" marL="0">
+            <a:pPr marL="0" indent="0">
               <a:buNone/>
             </a:pPr>
             <a:r>
@@ -9203,7 +9191,7 @@
             <a:prstDash val="solid"/>
           </a:ln>
           <a:effectLst>
-            <a:outerShdw sx="100000" sy="100000" kx="0" ky="0" algn="bl" rotWithShape="0" blurRad="101600" dist="12700" dir="5400000">
+            <a:outerShdw blurRad="101600" dist="12700" dir="5400000" sx="100000" sy="100000" kx="0" ky="0" algn="bl" rotWithShape="0">
               <a:srgbClr val="000000">
                 <a:alpha val="8000"/>
               </a:srgbClr>
@@ -9257,7 +9245,7 @@
           <a:bodyPr wrap="square" lIns="0" tIns="0" rIns="0" bIns="0" rtlCol="0" anchor="ctr"/>
           <a:lstStyle/>
           <a:p>
-            <a:pPr algn="ctr" indent="0" marL="0">
+            <a:pPr marL="0" indent="0" algn="ctr">
               <a:buNone/>
             </a:pPr>
             <a:r>
@@ -9296,7 +9284,7 @@
           <a:bodyPr wrap="square" lIns="0" tIns="0" rIns="0" bIns="0" rtlCol="0" anchor="ctr"/>
           <a:lstStyle/>
           <a:p>
-            <a:pPr indent="0" marL="0">
+            <a:pPr marL="0" indent="0">
               <a:buNone/>
             </a:pPr>
             <a:r>
@@ -9335,7 +9323,7 @@
           <a:bodyPr wrap="square" lIns="0" tIns="0" rIns="0" bIns="0" rtlCol="0" anchor="ctr"/>
           <a:lstStyle/>
           <a:p>
-            <a:pPr indent="0" marL="0">
+            <a:pPr marL="0" indent="0">
               <a:buNone/>
             </a:pPr>
             <a:r>
@@ -9379,7 +9367,7 @@
             <a:prstDash val="solid"/>
           </a:ln>
           <a:effectLst>
-            <a:outerShdw sx="100000" sy="100000" kx="0" ky="0" algn="bl" rotWithShape="0" blurRad="101600" dist="12700" dir="5400000">
+            <a:outerShdw blurRad="101600" dist="12700" dir="5400000" sx="100000" sy="100000" kx="0" ky="0" algn="bl" rotWithShape="0">
               <a:srgbClr val="000000">
                 <a:alpha val="8000"/>
               </a:srgbClr>
@@ -9433,7 +9421,7 @@
           <a:bodyPr wrap="square" lIns="0" tIns="0" rIns="0" bIns="0" rtlCol="0" anchor="ctr"/>
           <a:lstStyle/>
           <a:p>
-            <a:pPr algn="ctr" indent="0" marL="0">
+            <a:pPr marL="0" indent="0" algn="ctr">
               <a:buNone/>
             </a:pPr>
             <a:r>
@@ -9472,7 +9460,7 @@
           <a:bodyPr wrap="square" lIns="0" tIns="0" rIns="0" bIns="0" rtlCol="0" anchor="ctr"/>
           <a:lstStyle/>
           <a:p>
-            <a:pPr indent="0" marL="0">
+            <a:pPr marL="0" indent="0">
               <a:buNone/>
             </a:pPr>
             <a:r>
@@ -9511,7 +9499,7 @@
           <a:bodyPr wrap="square" lIns="0" tIns="0" rIns="0" bIns="0" rtlCol="0" anchor="ctr"/>
           <a:lstStyle/>
           <a:p>
-            <a:pPr indent="0" marL="0">
+            <a:pPr marL="0" indent="0">
               <a:buNone/>
             </a:pPr>
             <a:r>
@@ -9582,11 +9570,11 @@
           <a:bodyPr wrap="square" lIns="0" tIns="0" rIns="0" bIns="0" rtlCol="0" anchor="ctr"/>
           <a:lstStyle/>
           <a:p>
-            <a:pPr indent="0" marL="0">
-              <a:buNone/>
-            </a:pPr>
-            <a:r>
-              <a:rPr lang="en-US" sz="1200" b="1" spc="200" kern="0" dirty="0">
+            <a:pPr marL="0" indent="0">
+              <a:buNone/>
+            </a:pPr>
+            <a:r>
+              <a:rPr lang="en-US" sz="1200" b="1" kern="0" spc="200" dirty="0">
                 <a:solidFill>
                   <a:srgbClr val="5A5F73"/>
                 </a:solidFill>
@@ -9621,7 +9609,7 @@
           <a:bodyPr wrap="square" lIns="0" tIns="0" rIns="0" bIns="0" rtlCol="0" anchor="ctr"/>
           <a:lstStyle/>
           <a:p>
-            <a:pPr indent="0" marL="0">
+            <a:pPr marL="0" indent="0">
               <a:buNone/>
             </a:pPr>
             <a:r>
@@ -9665,7 +9653,7 @@
             <a:prstDash val="solid"/>
           </a:ln>
           <a:effectLst>
-            <a:outerShdw sx="100000" sy="100000" kx="0" ky="0" algn="bl" rotWithShape="0" blurRad="101600" dist="12700" dir="5400000">
+            <a:outerShdw blurRad="101600" dist="12700" dir="5400000" sx="100000" sy="100000" kx="0" ky="0" algn="bl" rotWithShape="0">
               <a:srgbClr val="000000">
                 <a:alpha val="8000"/>
               </a:srgbClr>
@@ -9694,7 +9682,7 @@
           <a:bodyPr wrap="square" lIns="0" tIns="0" rIns="0" bIns="0" rtlCol="0" anchor="ctr"/>
           <a:lstStyle/>
           <a:p>
-            <a:pPr indent="0" marL="0">
+            <a:pPr marL="0" indent="0">
               <a:buNone/>
             </a:pPr>
             <a:r>
@@ -9823,7 +9811,7 @@
             <a:prstDash val="solid"/>
           </a:ln>
           <a:effectLst>
-            <a:outerShdw sx="100000" sy="100000" kx="0" ky="0" algn="bl" rotWithShape="0" blurRad="101600" dist="12700" dir="5400000">
+            <a:outerShdw blurRad="101600" dist="12700" dir="5400000" sx="100000" sy="100000" kx="0" ky="0" algn="bl" rotWithShape="0">
               <a:srgbClr val="000000">
                 <a:alpha val="8000"/>
               </a:srgbClr>
@@ -9852,7 +9840,7 @@
           <a:bodyPr wrap="square" lIns="0" tIns="0" rIns="0" bIns="0" rtlCol="0" anchor="ctr"/>
           <a:lstStyle/>
           <a:p>
-            <a:pPr indent="0" marL="0">
+            <a:pPr marL="0" indent="0">
               <a:buNone/>
             </a:pPr>
             <a:r>
@@ -10071,11 +10059,11 @@
           <a:bodyPr wrap="square" lIns="0" tIns="0" rIns="0" bIns="0" rtlCol="0" anchor="ctr"/>
           <a:lstStyle/>
           <a:p>
-            <a:pPr indent="0" marL="0">
-              <a:buNone/>
-            </a:pPr>
-            <a:r>
-              <a:rPr lang="en-US" sz="1200" b="1" spc="200" kern="0" dirty="0">
+            <a:pPr marL="0" indent="0">
+              <a:buNone/>
+            </a:pPr>
+            <a:r>
+              <a:rPr lang="en-US" sz="1200" b="1" kern="0" spc="200" dirty="0">
                 <a:solidFill>
                   <a:srgbClr val="5A5F73"/>
                 </a:solidFill>
@@ -10110,7 +10098,7 @@
           <a:bodyPr wrap="square" lIns="0" tIns="0" rIns="0" bIns="0" rtlCol="0" anchor="ctr"/>
           <a:lstStyle/>
           <a:p>
-            <a:pPr indent="0" marL="0">
+            <a:pPr marL="0" indent="0">
               <a:buNone/>
             </a:pPr>
             <a:r>
@@ -10154,7 +10142,7 @@
             <a:prstDash val="solid"/>
           </a:ln>
           <a:effectLst>
-            <a:outerShdw sx="100000" sy="100000" kx="0" ky="0" algn="bl" rotWithShape="0" blurRad="101600" dist="12700" dir="5400000">
+            <a:outerShdw blurRad="101600" dist="12700" dir="5400000" sx="100000" sy="100000" kx="0" ky="0" algn="bl" rotWithShape="0">
               <a:srgbClr val="000000">
                 <a:alpha val="8000"/>
               </a:srgbClr>
@@ -10210,7 +10198,7 @@
           <a:bodyPr wrap="square" lIns="0" tIns="0" rIns="0" bIns="0" rtlCol="0" anchor="ctr"/>
           <a:lstStyle/>
           <a:p>
-            <a:pPr indent="0" marL="0">
+            <a:pPr marL="0" indent="0">
               <a:buNone/>
             </a:pPr>
             <a:r>
@@ -10249,7 +10237,7 @@
           <a:bodyPr wrap="square" lIns="0" tIns="0" rIns="0" bIns="0" rtlCol="0" anchor="ctr"/>
           <a:lstStyle/>
           <a:p>
-            <a:pPr algn="r" indent="0" marL="0">
+            <a:pPr marL="0" indent="0" algn="r">
               <a:buNone/>
             </a:pPr>
             <a:r>
@@ -10441,7 +10429,7 @@
             <a:prstDash val="solid"/>
           </a:ln>
           <a:effectLst>
-            <a:outerShdw sx="100000" sy="100000" kx="0" ky="0" algn="bl" rotWithShape="0" blurRad="101600" dist="12700" dir="5400000">
+            <a:outerShdw blurRad="101600" dist="12700" dir="5400000" sx="100000" sy="100000" kx="0" ky="0" algn="bl" rotWithShape="0">
               <a:srgbClr val="000000">
                 <a:alpha val="8000"/>
               </a:srgbClr>
@@ -10497,7 +10485,7 @@
           <a:bodyPr wrap="square" lIns="0" tIns="0" rIns="0" bIns="0" rtlCol="0" anchor="ctr"/>
           <a:lstStyle/>
           <a:p>
-            <a:pPr indent="0" marL="0">
+            <a:pPr marL="0" indent="0">
               <a:buNone/>
             </a:pPr>
             <a:r>
@@ -10536,7 +10524,7 @@
           <a:bodyPr wrap="square" lIns="0" tIns="0" rIns="0" bIns="0" rtlCol="0" anchor="ctr"/>
           <a:lstStyle/>
           <a:p>
-            <a:pPr algn="r" indent="0" marL="0">
+            <a:pPr marL="0" indent="0" algn="r">
               <a:buNone/>
             </a:pPr>
             <a:r>
@@ -10728,7 +10716,7 @@
             <a:prstDash val="solid"/>
           </a:ln>
           <a:effectLst>
-            <a:outerShdw sx="100000" sy="100000" kx="0" ky="0" algn="bl" rotWithShape="0" blurRad="101600" dist="12700" dir="5400000">
+            <a:outerShdw blurRad="101600" dist="12700" dir="5400000" sx="100000" sy="100000" kx="0" ky="0" algn="bl" rotWithShape="0">
               <a:srgbClr val="000000">
                 <a:alpha val="8000"/>
               </a:srgbClr>
@@ -10784,7 +10772,7 @@
           <a:bodyPr wrap="square" lIns="0" tIns="0" rIns="0" bIns="0" rtlCol="0" anchor="ctr"/>
           <a:lstStyle/>
           <a:p>
-            <a:pPr indent="0" marL="0">
+            <a:pPr marL="0" indent="0">
               <a:buNone/>
             </a:pPr>
             <a:r>
@@ -10823,7 +10811,7 @@
           <a:bodyPr wrap="square" lIns="0" tIns="0" rIns="0" bIns="0" rtlCol="0" anchor="ctr"/>
           <a:lstStyle/>
           <a:p>
-            <a:pPr algn="r" indent="0" marL="0">
+            <a:pPr marL="0" indent="0" algn="r">
               <a:buNone/>
             </a:pPr>
             <a:r>
@@ -10989,7 +10977,7 @@
           <a:bodyPr wrap="square" lIns="0" tIns="0" rIns="0" bIns="0" rtlCol="0" anchor="ctr"/>
           <a:lstStyle/>
           <a:p>
-            <a:pPr indent="0" marL="0">
+            <a:pPr marL="0" indent="0">
               <a:buNone/>
             </a:pPr>
             <a:r>
@@ -11060,11 +11048,11 @@
           <a:bodyPr wrap="square" lIns="0" tIns="0" rIns="0" bIns="0" rtlCol="0" anchor="ctr"/>
           <a:lstStyle/>
           <a:p>
-            <a:pPr indent="0" marL="0">
-              <a:buNone/>
-            </a:pPr>
-            <a:r>
-              <a:rPr lang="en-US" sz="1200" b="1" spc="200" kern="0" dirty="0">
+            <a:pPr marL="0" indent="0">
+              <a:buNone/>
+            </a:pPr>
+            <a:r>
+              <a:rPr lang="en-US" sz="1200" b="1" kern="0" spc="200" dirty="0">
                 <a:solidFill>
                   <a:srgbClr val="5A5F73"/>
                 </a:solidFill>
@@ -11099,7 +11087,7 @@
           <a:bodyPr wrap="square" lIns="0" tIns="0" rIns="0" bIns="0" rtlCol="0" anchor="ctr"/>
           <a:lstStyle/>
           <a:p>
-            <a:pPr indent="0" marL="0">
+            <a:pPr marL="0" indent="0">
               <a:buNone/>
             </a:pPr>
             <a:r>
@@ -11163,7 +11151,7 @@
           <a:bodyPr wrap="square" lIns="0" tIns="0" rIns="0" bIns="0" rtlCol="0" anchor="ctr"/>
           <a:lstStyle/>
           <a:p>
-            <a:pPr algn="ctr" indent="0" marL="0">
+            <a:pPr marL="0" indent="0" algn="ctr">
               <a:buNone/>
             </a:pPr>
             <a:r>
@@ -11202,7 +11190,7 @@
           <a:bodyPr wrap="square" lIns="0" tIns="0" rIns="0" bIns="0" rtlCol="0" anchor="ctr"/>
           <a:lstStyle/>
           <a:p>
-            <a:pPr indent="0" marL="0">
+            <a:pPr marL="0" indent="0">
               <a:buNone/>
             </a:pPr>
             <a:r>
@@ -11241,7 +11229,7 @@
           <a:bodyPr wrap="square" lIns="0" tIns="0" rIns="0" bIns="0" rtlCol="0" anchor="ctr"/>
           <a:lstStyle/>
           <a:p>
-            <a:pPr indent="0" marL="0">
+            <a:pPr marL="0" indent="0">
               <a:buNone/>
             </a:pPr>
             <a:r>
@@ -11305,7 +11293,7 @@
           <a:bodyPr wrap="square" lIns="0" tIns="0" rIns="0" bIns="0" rtlCol="0" anchor="ctr"/>
           <a:lstStyle/>
           <a:p>
-            <a:pPr algn="ctr" indent="0" marL="0">
+            <a:pPr marL="0" indent="0" algn="ctr">
               <a:buNone/>
             </a:pPr>
             <a:r>
@@ -11344,7 +11332,7 @@
           <a:bodyPr wrap="square" lIns="0" tIns="0" rIns="0" bIns="0" rtlCol="0" anchor="ctr"/>
           <a:lstStyle/>
           <a:p>
-            <a:pPr indent="0" marL="0">
+            <a:pPr marL="0" indent="0">
               <a:buNone/>
             </a:pPr>
             <a:r>
@@ -11383,7 +11371,7 @@
           <a:bodyPr wrap="square" lIns="0" tIns="0" rIns="0" bIns="0" rtlCol="0" anchor="ctr"/>
           <a:lstStyle/>
           <a:p>
-            <a:pPr indent="0" marL="0">
+            <a:pPr marL="0" indent="0">
               <a:buNone/>
             </a:pPr>
             <a:r>
@@ -11447,7 +11435,7 @@
           <a:bodyPr wrap="square" lIns="0" tIns="0" rIns="0" bIns="0" rtlCol="0" anchor="ctr"/>
           <a:lstStyle/>
           <a:p>
-            <a:pPr algn="ctr" indent="0" marL="0">
+            <a:pPr marL="0" indent="0" algn="ctr">
               <a:buNone/>
             </a:pPr>
             <a:r>
@@ -11486,7 +11474,7 @@
           <a:bodyPr wrap="square" lIns="0" tIns="0" rIns="0" bIns="0" rtlCol="0" anchor="ctr"/>
           <a:lstStyle/>
           <a:p>
-            <a:pPr indent="0" marL="0">
+            <a:pPr marL="0" indent="0">
               <a:buNone/>
             </a:pPr>
             <a:r>
@@ -11525,7 +11513,7 @@
           <a:bodyPr wrap="square" lIns="0" tIns="0" rIns="0" bIns="0" rtlCol="0" anchor="ctr"/>
           <a:lstStyle/>
           <a:p>
-            <a:pPr indent="0" marL="0">
+            <a:pPr marL="0" indent="0">
               <a:buNone/>
             </a:pPr>
             <a:r>
@@ -11589,7 +11577,7 @@
           <a:bodyPr wrap="square" lIns="0" tIns="0" rIns="0" bIns="0" rtlCol="0" anchor="ctr"/>
           <a:lstStyle/>
           <a:p>
-            <a:pPr algn="ctr" indent="0" marL="0">
+            <a:pPr marL="0" indent="0" algn="ctr">
               <a:buNone/>
             </a:pPr>
             <a:r>
@@ -11628,7 +11616,7 @@
           <a:bodyPr wrap="square" lIns="0" tIns="0" rIns="0" bIns="0" rtlCol="0" anchor="ctr"/>
           <a:lstStyle/>
           <a:p>
-            <a:pPr indent="0" marL="0">
+            <a:pPr marL="0" indent="0">
               <a:buNone/>
             </a:pPr>
             <a:r>
@@ -11667,7 +11655,7 @@
           <a:bodyPr wrap="square" lIns="0" tIns="0" rIns="0" bIns="0" rtlCol="0" anchor="ctr"/>
           <a:lstStyle/>
           <a:p>
-            <a:pPr indent="0" marL="0">
+            <a:pPr marL="0" indent="0">
               <a:buNone/>
             </a:pPr>
             <a:r>
@@ -11731,7 +11719,7 @@
           <a:bodyPr wrap="square" lIns="0" tIns="0" rIns="0" bIns="0" rtlCol="0" anchor="ctr"/>
           <a:lstStyle/>
           <a:p>
-            <a:pPr algn="ctr" indent="0" marL="0">
+            <a:pPr marL="0" indent="0" algn="ctr">
               <a:buNone/>
             </a:pPr>
             <a:r>
@@ -11770,7 +11758,7 @@
           <a:bodyPr wrap="square" lIns="0" tIns="0" rIns="0" bIns="0" rtlCol="0" anchor="ctr"/>
           <a:lstStyle/>
           <a:p>
-            <a:pPr indent="0" marL="0">
+            <a:pPr marL="0" indent="0">
               <a:buNone/>
             </a:pPr>
             <a:r>
@@ -11809,7 +11797,7 @@
           <a:bodyPr wrap="square" lIns="0" tIns="0" rIns="0" bIns="0" rtlCol="0" anchor="ctr"/>
           <a:lstStyle/>
           <a:p>
-            <a:pPr indent="0" marL="0">
+            <a:pPr marL="0" indent="0">
               <a:buNone/>
             </a:pPr>
             <a:r>
@@ -11873,7 +11861,7 @@
           <a:bodyPr wrap="square" lIns="0" tIns="0" rIns="0" bIns="0" rtlCol="0" anchor="ctr"/>
           <a:lstStyle/>
           <a:p>
-            <a:pPr algn="ctr" indent="0" marL="0">
+            <a:pPr marL="0" indent="0" algn="ctr">
               <a:buNone/>
             </a:pPr>
             <a:r>
@@ -11912,7 +11900,7 @@
           <a:bodyPr wrap="square" lIns="0" tIns="0" rIns="0" bIns="0" rtlCol="0" anchor="ctr"/>
           <a:lstStyle/>
           <a:p>
-            <a:pPr indent="0" marL="0">
+            <a:pPr marL="0" indent="0">
               <a:buNone/>
             </a:pPr>
             <a:r>
@@ -11951,7 +11939,7 @@
           <a:bodyPr wrap="square" lIns="0" tIns="0" rIns="0" bIns="0" rtlCol="0" anchor="ctr"/>
           <a:lstStyle/>
           <a:p>
-            <a:pPr indent="0" marL="0">
+            <a:pPr marL="0" indent="0">
               <a:buNone/>
             </a:pPr>
             <a:r>
@@ -12022,11 +12010,11 @@
           <a:bodyPr wrap="square" lIns="0" tIns="0" rIns="0" bIns="0" rtlCol="0" anchor="ctr"/>
           <a:lstStyle/>
           <a:p>
-            <a:pPr indent="0" marL="0">
-              <a:buNone/>
-            </a:pPr>
-            <a:r>
-              <a:rPr lang="en-US" sz="1200" b="1" spc="200" kern="0" dirty="0">
+            <a:pPr marL="0" indent="0">
+              <a:buNone/>
+            </a:pPr>
+            <a:r>
+              <a:rPr lang="en-US" sz="1200" b="1" kern="0" spc="200" dirty="0">
                 <a:solidFill>
                   <a:srgbClr val="5A5F73"/>
                 </a:solidFill>
@@ -12061,7 +12049,7 @@
           <a:bodyPr wrap="square" lIns="0" tIns="0" rIns="0" bIns="0" rtlCol="0" anchor="ctr"/>
           <a:lstStyle/>
           <a:p>
-            <a:pPr indent="0" marL="0">
+            <a:pPr marL="0" indent="0">
               <a:buNone/>
             </a:pPr>
             <a:r>
@@ -12081,7 +12069,7 @@
       </p:sp>
       <p:pic>
         <p:nvPicPr>
-          <p:cNvPr id="4" name="Image 0" descr="preencoded.png">    </p:cNvPr>
+          <p:cNvPr id="4" name="Image 0" descr="preencoded.png"/>
           <p:cNvPicPr>
             <a:picLocks noChangeAspect="1"/>
           </p:cNvPicPr>
@@ -12124,7 +12112,7 @@
           <a:bodyPr wrap="square" lIns="0" tIns="0" rIns="0" bIns="0" rtlCol="0" anchor="ctr"/>
           <a:lstStyle/>
           <a:p>
-            <a:pPr indent="0" marL="0">
+            <a:pPr marL="0" indent="0">
               <a:buNone/>
             </a:pPr>
             <a:r>
@@ -12163,7 +12151,7 @@
           <a:bodyPr wrap="square" lIns="0" tIns="0" rIns="0" bIns="0" rtlCol="0" anchor="ctr"/>
           <a:lstStyle/>
           <a:p>
-            <a:pPr indent="0" marL="0">
+            <a:pPr marL="0" indent="0">
               <a:buNone/>
             </a:pPr>
             <a:r>
@@ -12202,7 +12190,7 @@
           <a:bodyPr wrap="square" lIns="0" tIns="0" rIns="0" bIns="0" rtlCol="0" anchor="ctr"/>
           <a:lstStyle/>
           <a:p>
-            <a:pPr indent="0" marL="0">
+            <a:pPr marL="0" indent="0">
               <a:buNone/>
             </a:pPr>
             <a:r>
@@ -12241,7 +12229,7 @@
           <a:bodyPr wrap="square" lIns="0" tIns="0" rIns="0" bIns="0" rtlCol="0" anchor="ctr"/>
           <a:lstStyle/>
           <a:p>
-            <a:pPr indent="0" marL="0">
+            <a:pPr marL="0" indent="0">
               <a:buNone/>
             </a:pPr>
             <a:r>
@@ -12280,7 +12268,7 @@
           <a:bodyPr wrap="square" lIns="0" tIns="0" rIns="0" bIns="0" rtlCol="0" anchor="ctr"/>
           <a:lstStyle/>
           <a:p>
-            <a:pPr indent="0" marL="0">
+            <a:pPr marL="0" indent="0">
               <a:buNone/>
             </a:pPr>
             <a:r>
@@ -12319,7 +12307,7 @@
           <a:bodyPr wrap="square" lIns="0" tIns="0" rIns="0" bIns="0" rtlCol="0" anchor="ctr"/>
           <a:lstStyle/>
           <a:p>
-            <a:pPr indent="0" marL="0">
+            <a:pPr marL="0" indent="0">
               <a:buNone/>
             </a:pPr>
             <a:r>
@@ -12358,7 +12346,7 @@
           <a:bodyPr wrap="square" lIns="0" tIns="0" rIns="0" bIns="0" rtlCol="0" anchor="ctr"/>
           <a:lstStyle/>
           <a:p>
-            <a:pPr indent="0" marL="0">
+            <a:pPr marL="0" indent="0">
               <a:buNone/>
             </a:pPr>
             <a:r>
@@ -12397,7 +12385,7 @@
           <a:bodyPr wrap="square" lIns="0" tIns="0" rIns="0" bIns="0" rtlCol="0" anchor="ctr"/>
           <a:lstStyle/>
           <a:p>
-            <a:pPr indent="0" marL="0">
+            <a:pPr marL="0" indent="0">
               <a:buNone/>
             </a:pPr>
             <a:r>
@@ -12468,11 +12456,11 @@
           <a:bodyPr wrap="square" lIns="0" tIns="0" rIns="0" bIns="0" rtlCol="0" anchor="ctr"/>
           <a:lstStyle/>
           <a:p>
-            <a:pPr indent="0" marL="0">
-              <a:buNone/>
-            </a:pPr>
-            <a:r>
-              <a:rPr lang="en-US" sz="1200" b="1" spc="200" kern="0" dirty="0">
+            <a:pPr marL="0" indent="0">
+              <a:buNone/>
+            </a:pPr>
+            <a:r>
+              <a:rPr lang="en-US" sz="1200" b="1" kern="0" spc="200" dirty="0">
                 <a:solidFill>
                   <a:srgbClr val="5A5F73"/>
                 </a:solidFill>
@@ -12507,7 +12495,7 @@
           <a:bodyPr wrap="square" lIns="0" tIns="0" rIns="0" bIns="0" rtlCol="0" anchor="ctr"/>
           <a:lstStyle/>
           <a:p>
-            <a:pPr indent="0" marL="0">
+            <a:pPr marL="0" indent="0">
               <a:buNone/>
             </a:pPr>
             <a:r>
@@ -12527,7 +12515,7 @@
       </p:sp>
       <p:pic>
         <p:nvPicPr>
-          <p:cNvPr id="4" name="Image 0" descr="preencoded.png">    </p:cNvPr>
+          <p:cNvPr id="4" name="Image 0" descr="preencoded.png"/>
           <p:cNvPicPr>
             <a:picLocks noChangeAspect="1"/>
           </p:cNvPicPr>
@@ -12570,7 +12558,7 @@
           <a:bodyPr wrap="square" lIns="0" tIns="0" rIns="0" bIns="0" rtlCol="0" anchor="ctr"/>
           <a:lstStyle/>
           <a:p>
-            <a:pPr indent="0" marL="0">
+            <a:pPr marL="0" indent="0">
               <a:buNone/>
             </a:pPr>
             <a:r>
@@ -12609,7 +12597,7 @@
           <a:bodyPr wrap="square" lIns="0" tIns="0" rIns="0" bIns="0" rtlCol="0" anchor="ctr"/>
           <a:lstStyle/>
           <a:p>
-            <a:pPr indent="0" marL="0">
+            <a:pPr marL="0" indent="0">
               <a:buNone/>
             </a:pPr>
             <a:r>
@@ -12648,7 +12636,7 @@
           <a:bodyPr wrap="square" lIns="0" tIns="0" rIns="0" bIns="0" rtlCol="0" anchor="ctr"/>
           <a:lstStyle/>
           <a:p>
-            <a:pPr indent="0" marL="0">
+            <a:pPr marL="0" indent="0">
               <a:buNone/>
             </a:pPr>
             <a:r>
@@ -12719,11 +12707,11 @@
           <a:bodyPr wrap="square" lIns="0" tIns="0" rIns="0" bIns="0" rtlCol="0" anchor="ctr"/>
           <a:lstStyle/>
           <a:p>
-            <a:pPr indent="0" marL="0">
-              <a:buNone/>
-            </a:pPr>
-            <a:r>
-              <a:rPr lang="en-US" sz="1200" b="1" spc="200" kern="0" dirty="0">
+            <a:pPr marL="0" indent="0">
+              <a:buNone/>
+            </a:pPr>
+            <a:r>
+              <a:rPr lang="en-US" sz="1200" b="1" kern="0" spc="200" dirty="0">
                 <a:solidFill>
                   <a:srgbClr val="5A5F73"/>
                 </a:solidFill>
@@ -12758,7 +12746,7 @@
           <a:bodyPr wrap="square" lIns="0" tIns="0" rIns="0" bIns="0" rtlCol="0" anchor="ctr"/>
           <a:lstStyle/>
           <a:p>
-            <a:pPr indent="0" marL="0">
+            <a:pPr marL="0" indent="0">
               <a:buNone/>
             </a:pPr>
             <a:r>
@@ -12778,7 +12766,7 @@
       </p:sp>
       <p:pic>
         <p:nvPicPr>
-          <p:cNvPr id="4" name="Image 0" descr="preencoded.png">    </p:cNvPr>
+          <p:cNvPr id="4" name="Image 0" descr="preencoded.png"/>
           <p:cNvPicPr>
             <a:picLocks noChangeAspect="1"/>
           </p:cNvPicPr>
@@ -12826,7 +12814,7 @@
             <a:prstDash val="solid"/>
           </a:ln>
           <a:effectLst>
-            <a:outerShdw sx="100000" sy="100000" kx="0" ky="0" algn="bl" rotWithShape="0" blurRad="101600" dist="12700" dir="5400000">
+            <a:outerShdw blurRad="101600" dist="12700" dir="5400000" sx="100000" sy="100000" kx="0" ky="0" algn="bl" rotWithShape="0">
               <a:srgbClr val="000000">
                 <a:alpha val="8000"/>
               </a:srgbClr>
@@ -12855,7 +12843,7 @@
           <a:bodyPr wrap="square" lIns="0" tIns="0" rIns="0" bIns="0" rtlCol="0" anchor="ctr"/>
           <a:lstStyle/>
           <a:p>
-            <a:pPr indent="0" marL="0">
+            <a:pPr marL="0" indent="0">
               <a:buNone/>
             </a:pPr>
             <a:r>
@@ -12894,7 +12882,7 @@
           <a:bodyPr wrap="square" lIns="0" tIns="0" rIns="0" bIns="0" rtlCol="0" anchor="ctr"/>
           <a:lstStyle/>
           <a:p>
-            <a:pPr indent="0" marL="0">
+            <a:pPr marL="0" indent="0">
               <a:buNone/>
             </a:pPr>
             <a:r>
@@ -12938,7 +12926,7 @@
             <a:prstDash val="solid"/>
           </a:ln>
           <a:effectLst>
-            <a:outerShdw sx="100000" sy="100000" kx="0" ky="0" algn="bl" rotWithShape="0" blurRad="101600" dist="12700" dir="5400000">
+            <a:outerShdw blurRad="101600" dist="12700" dir="5400000" sx="100000" sy="100000" kx="0" ky="0" algn="bl" rotWithShape="0">
               <a:srgbClr val="000000">
                 <a:alpha val="8000"/>
               </a:srgbClr>
@@ -12967,7 +12955,7 @@
           <a:bodyPr wrap="square" lIns="0" tIns="0" rIns="0" bIns="0" rtlCol="0" anchor="ctr"/>
           <a:lstStyle/>
           <a:p>
-            <a:pPr indent="0" marL="0">
+            <a:pPr marL="0" indent="0">
               <a:buNone/>
             </a:pPr>
             <a:r>
@@ -13006,7 +12994,7 @@
           <a:bodyPr wrap="square" lIns="0" tIns="0" rIns="0" bIns="0" rtlCol="0" anchor="ctr"/>
           <a:lstStyle/>
           <a:p>
-            <a:pPr indent="0" marL="0">
+            <a:pPr marL="0" indent="0">
               <a:buNone/>
             </a:pPr>
             <a:r>
@@ -13077,11 +13065,11 @@
           <a:bodyPr wrap="square" lIns="0" tIns="0" rIns="0" bIns="0" rtlCol="0" anchor="ctr"/>
           <a:lstStyle/>
           <a:p>
-            <a:pPr indent="0" marL="0">
-              <a:buNone/>
-            </a:pPr>
-            <a:r>
-              <a:rPr lang="en-US" sz="1200" b="1" spc="300" kern="0" dirty="0">
+            <a:pPr marL="0" indent="0">
+              <a:buNone/>
+            </a:pPr>
+            <a:r>
+              <a:rPr lang="en-US" sz="1200" b="1" kern="0" spc="300" dirty="0">
                 <a:solidFill>
                   <a:srgbClr val="CADCFC"/>
                 </a:solidFill>
@@ -13116,7 +13104,7 @@
           <a:bodyPr wrap="square" lIns="0" tIns="0" rIns="0" bIns="0" rtlCol="0" anchor="ctr"/>
           <a:lstStyle/>
           <a:p>
-            <a:pPr indent="0" marL="0">
+            <a:pPr marL="0" indent="0">
               <a:buNone/>
             </a:pPr>
             <a:r>
@@ -13182,7 +13170,7 @@
           <a:bodyPr wrap="square" lIns="0" tIns="0" rIns="0" bIns="0" rtlCol="0" anchor="ctr"/>
           <a:lstStyle/>
           <a:p>
-            <a:pPr indent="0" marL="0">
+            <a:pPr marL="0" indent="0">
               <a:lnSpc>
                 <a:spcPts val="2000"/>
               </a:lnSpc>
@@ -13202,7 +13190,7 @@
             <a:endParaRPr lang="en-US" sz="1300" dirty="0"/>
           </a:p>
           <a:p>
-            <a:pPr indent="0" marL="0">
+            <a:pPr marL="0" indent="0">
               <a:lnSpc>
                 <a:spcPts val="2000"/>
               </a:lnSpc>
@@ -13222,7 +13210,7 @@
             <a:endParaRPr lang="en-US" sz="1300" dirty="0"/>
           </a:p>
           <a:p>
-            <a:pPr indent="0" marL="0">
+            <a:pPr marL="0" indent="0">
               <a:lnSpc>
                 <a:spcPts val="2000"/>
               </a:lnSpc>
@@ -13242,7 +13230,7 @@
             <a:endParaRPr lang="en-US" sz="1300" dirty="0"/>
           </a:p>
           <a:p>
-            <a:pPr indent="0" marL="0">
+            <a:pPr marL="0" indent="0">
               <a:lnSpc>
                 <a:spcPts val="2000"/>
               </a:lnSpc>
@@ -13262,7 +13250,7 @@
             <a:endParaRPr lang="en-US" sz="1300" dirty="0"/>
           </a:p>
           <a:p>
-            <a:pPr indent="0" marL="0">
+            <a:pPr marL="0" indent="0">
               <a:lnSpc>
                 <a:spcPts val="2000"/>
               </a:lnSpc>
@@ -13282,7 +13270,7 @@
             <a:endParaRPr lang="en-US" sz="1300" dirty="0"/>
           </a:p>
           <a:p>
-            <a:pPr indent="0" marL="0">
+            <a:pPr marL="0" indent="0">
               <a:lnSpc>
                 <a:spcPts val="2000"/>
               </a:lnSpc>
@@ -13302,7 +13290,7 @@
             <a:endParaRPr lang="en-US" sz="1300" dirty="0"/>
           </a:p>
           <a:p>
-            <a:pPr indent="0" marL="0">
+            <a:pPr marL="0" indent="0">
               <a:lnSpc>
                 <a:spcPts val="2000"/>
               </a:lnSpc>
@@ -13344,7 +13332,7 @@
           <a:bodyPr wrap="square" lIns="0" tIns="0" rIns="0" bIns="0" rtlCol="0" anchor="ctr"/>
           <a:lstStyle/>
           <a:p>
-            <a:pPr indent="0" marL="0">
+            <a:pPr marL="0" indent="0">
               <a:buNone/>
             </a:pPr>
             <a:r>
@@ -13383,7 +13371,7 @@
           <a:bodyPr wrap="square" lIns="0" tIns="0" rIns="0" bIns="0" rtlCol="0" anchor="ctr"/>
           <a:lstStyle/>
           <a:p>
-            <a:pPr indent="0" marL="0">
+            <a:pPr marL="0" indent="0">
               <a:buNone/>
             </a:pPr>
             <a:r>
@@ -13422,7 +13410,7 @@
           <a:bodyPr wrap="square" lIns="0" tIns="0" rIns="0" bIns="0" rtlCol="0" anchor="ctr"/>
           <a:lstStyle/>
           <a:p>
-            <a:pPr indent="0" marL="0">
+            <a:pPr marL="0" indent="0">
               <a:buNone/>
             </a:pPr>
             <a:r>
@@ -13461,7 +13449,7 @@
           <a:bodyPr wrap="square" lIns="0" tIns="0" rIns="0" bIns="0" rtlCol="0" anchor="ctr"/>
           <a:lstStyle/>
           <a:p>
-            <a:pPr indent="0" marL="0">
+            <a:pPr marL="0" indent="0">
               <a:buNone/>
             </a:pPr>
             <a:r>
@@ -13500,7 +13488,7 @@
           <a:bodyPr wrap="square" lIns="0" tIns="0" rIns="0" bIns="0" rtlCol="0" anchor="ctr"/>
           <a:lstStyle/>
           <a:p>
-            <a:pPr indent="0" marL="0">
+            <a:pPr marL="0" indent="0">
               <a:buNone/>
             </a:pPr>
             <a:r>
@@ -13539,7 +13527,7 @@
           <a:bodyPr wrap="square" lIns="0" tIns="0" rIns="0" bIns="0" rtlCol="0" anchor="ctr"/>
           <a:lstStyle/>
           <a:p>
-            <a:pPr indent="0" marL="0">
+            <a:pPr marL="0" indent="0">
               <a:buNone/>
             </a:pPr>
             <a:r>
@@ -13578,7 +13566,7 @@
           <a:bodyPr wrap="square" lIns="0" tIns="0" rIns="0" bIns="0" rtlCol="0" anchor="ctr"/>
           <a:lstStyle/>
           <a:p>
-            <a:pPr indent="0" marL="0">
+            <a:pPr marL="0" indent="0">
               <a:buNone/>
             </a:pPr>
             <a:r>

</xml_diff>